<commit_message>
Add LangGraph Studio slide with real screenshot to focused deck
New slide (real Studio screenshot from the open-source langgraph-engineer by
Harrison Chase) showing the graph view + thread/state panel, with annotated
callouts and source attribution. Deck now 10 slides.

Co-Authored-By: Claude Opus 4.8 <noreply@anthropic.com>
</commit_message>
<xml_diff>
--- a/LangChain_LangGraph_Workshop.pptx
+++ b/LangChain_LangGraph_Workshop.pptx
@@ -14,9 +14,10 @@
     <p:sldId id="262" r:id="rId8"/>
     <p:sldId id="263" r:id="rId9"/>
     <p:sldId id="264" r:id="rId10"/>
+    <p:sldId id="265" r:id="rId11"/>
   </p:sldIdLst>
   <p:notesMasterIdLst>
-    <p:notesMasterId r:id="rId11"/>
+    <p:notesMasterId r:id="rId12"/>
   </p:notesMasterIdLst>
   <p:sldSz cx="12192000" cy="6858000"/>
   <p:notesSz cx="6858000" cy="12192000"/>
@@ -552,6 +553,94 @@
 </p:notes>
 </file>
 
+<file path=ppt/notesSlides/notesSlide10.xml><?xml version="1.0" encoding="utf-8"?>
+<p:notes xmlns:a="http://schemas.openxmlformats.org/drawingml/2006/main" xmlns:r="http://schemas.openxmlformats.org/officeDocument/2006/relationships" xmlns:p="http://schemas.openxmlformats.org/presentationml/2006/main">
+  <p:cSld>
+    <p:spTree>
+      <p:nvGrpSpPr>
+        <p:cNvPr id="1" name=""/>
+        <p:cNvGrpSpPr/>
+        <p:nvPr/>
+      </p:nvGrpSpPr>
+      <p:grpSpPr>
+        <a:xfrm>
+          <a:off x="0" y="0"/>
+          <a:ext cx="0" cy="0"/>
+          <a:chOff x="0" y="0"/>
+          <a:chExt cx="0" cy="0"/>
+        </a:xfrm>
+      </p:grpSpPr>
+      <p:sp>
+        <p:nvSpPr>
+          <p:cNvPr id="2" name="Slide Image Placeholder 1"/>
+          <p:cNvSpPr>
+            <a:spLocks noGrp="1" noRot="1" noChangeAspect="1"/>
+          </p:cNvSpPr>
+          <p:nvPr>
+            <p:ph type="sldImg"/>
+          </p:nvPr>
+        </p:nvSpPr>
+        <p:spPr/>
+      </p:sp>
+      <p:sp>
+        <p:nvSpPr>
+          <p:cNvPr id="3" name="Notes Placeholder 2"/>
+          <p:cNvSpPr>
+            <a:spLocks noGrp="1"/>
+          </p:cNvSpPr>
+          <p:nvPr>
+            <p:ph type="body" idx="1"/>
+          </p:nvPr>
+        </p:nvSpPr>
+        <p:spPr/>
+        <p:txBody>
+          <a:bodyPr/>
+          <a:lstStyle/>
+          <a:p>
+            <a:r>
+              <a:rPr lang="en-US" dirty="0"/>
+              <a:t>Close on the one-liner: LangChain builds the pieces, LangGraph makes them an agent. Point them back at the two notebooks. Q&amp;A.</a:t>
+            </a:r>
+            <a:endParaRPr lang="en-US" dirty="0"/>
+          </a:p>
+        </p:txBody>
+      </p:sp>
+      <p:sp>
+        <p:nvSpPr>
+          <p:cNvPr id="4" name="Slide Number Placeholder 3"/>
+          <p:cNvSpPr>
+            <a:spLocks noGrp="1"/>
+          </p:cNvSpPr>
+          <p:nvPr>
+            <p:ph type="sldNum" sz="quarter" idx="10"/>
+          </p:nvPr>
+        </p:nvSpPr>
+        <p:spPr/>
+        <p:txBody>
+          <a:bodyPr/>
+          <a:lstStyle/>
+          <a:p>
+            <a:fld id="{F7021451-1387-4CA6-816F-3879F97B5CBC}" type="slidenum">
+              <a:rPr lang="en-US"/>
+              <a:t>10</a:t>
+            </a:fld>
+            <a:endParaRPr lang="en-US"/>
+          </a:p>
+        </p:txBody>
+      </p:sp>
+    </p:spTree>
+    <p:extLst>
+      <p:ext uri="{BB962C8B-B14F-4D97-AF65-F5344CB8AC3E}">
+        <p14:creationId xmlns:p14="http://schemas.microsoft.com/office/powerpoint/2010/main" val="1024086991"/>
+      </p:ext>
+    </p:extLst>
+  </p:cSld>
+  <p:clrMapOvr>
+    <a:masterClrMapping/>
+  </p:clrMapOvr>
+</p:notes>
+</file>
+
 <file path=ppt/notesSlides/notesSlide2.xml><?xml version="1.0" encoding="utf-8"?>
 <p:notes xmlns:a="http://schemas.openxmlformats.org/drawingml/2006/main" xmlns:r="http://schemas.openxmlformats.org/officeDocument/2006/relationships" xmlns:p="http://schemas.openxmlformats.org/presentationml/2006/main">
   <p:cSld>
@@ -1038,7 +1127,7 @@
           <a:p>
             <a:r>
               <a:rPr lang="en-US" dirty="0"/>
-              <a:t>Two notebooks, run top to bottom, each ending in a build-it-yourself exercise. Then we open Studio to see a graph execute visually.</a:t>
+              <a:t>This is Studio on a real agent. Left: the graph rendered from code — start, gather_requirements, draft_answer looping with check, critique, end. Right: the thread with messages, state, and even generated code. Launch it with `langgraph dev`; submit an input, watch the path light up, open a node to inspect state, then fork and replay. Screenshot is from Harrison Chase's open-source langgraph-engineer.</a:t>
             </a:r>
             <a:endParaRPr lang="en-US" dirty="0"/>
           </a:p>
@@ -1126,7 +1215,7 @@
           <a:p>
             <a:r>
               <a:rPr lang="en-US" dirty="0"/>
-              <a:t>Switch to JupyterLab. Run notebook 1, then notebook 2, pausing at each exercise. Studio at the end.</a:t>
+              <a:t>Two notebooks, run top to bottom, each ending in a build-it-yourself exercise. Then we open Studio to see a graph execute visually.</a:t>
             </a:r>
             <a:endParaRPr lang="en-US" dirty="0"/>
           </a:p>
@@ -1214,7 +1303,7 @@
           <a:p>
             <a:r>
               <a:rPr lang="en-US" dirty="0"/>
-              <a:t>Close on the one-liner: LangChain builds the pieces, LangGraph makes them an agent. Point them back at the two notebooks. Q&amp;A.</a:t>
+              <a:t>Switch to JupyterLab. Run notebook 1, then notebook 2, pausing at each exercise. Studio at the end.</a:t>
             </a:r>
             <a:endParaRPr lang="en-US" dirty="0"/>
           </a:p>
@@ -1810,6 +1899,340 @@
 </p:sld>
 </file>
 
+<file path=ppt/slides/slide10.xml><?xml version="1.0" encoding="utf-8"?>
+<p:sld xmlns:a="http://schemas.openxmlformats.org/drawingml/2006/main" xmlns:r="http://schemas.openxmlformats.org/officeDocument/2006/relationships" xmlns:p="http://schemas.openxmlformats.org/presentationml/2006/main">
+  <p:cSld name="Slide 10">
+    <p:bg>
+      <p:bgPr>
+        <a:solidFill>
+          <a:srgbClr val="0B1220"/>
+        </a:solidFill>
+      </p:bgPr>
+    </p:bg>
+    <p:spTree>
+      <p:nvGrpSpPr>
+        <p:cNvPr id="1" name=""/>
+        <p:cNvGrpSpPr/>
+        <p:nvPr/>
+      </p:nvGrpSpPr>
+      <p:grpSpPr>
+        <a:xfrm>
+          <a:off x="0" y="0"/>
+          <a:ext cx="0" cy="0"/>
+          <a:chOff x="0" y="0"/>
+          <a:chExt cx="0" cy="0"/>
+        </a:xfrm>
+      </p:grpSpPr>
+      <p:sp>
+        <p:nvSpPr>
+          <p:cNvPr id="2" name="Shape 0"/>
+          <p:cNvSpPr/>
+          <p:nvPr/>
+        </p:nvSpPr>
+        <p:spPr>
+          <a:xfrm>
+            <a:off x="-1828800" y="4023360"/>
+            <a:ext cx="5486400" cy="5486400"/>
+          </a:xfrm>
+          <a:prstGeom prst="ellipse">
+            <a:avLst/>
+          </a:prstGeom>
+          <a:solidFill>
+            <a:srgbClr val="0F1A30"/>
+          </a:solidFill>
+          <a:ln w="12700">
+            <a:solidFill>
+              <a:srgbClr val="24334F"/>
+            </a:solidFill>
+            <a:prstDash val="solid"/>
+          </a:ln>
+        </p:spPr>
+      </p:sp>
+      <p:sp>
+        <p:nvSpPr>
+          <p:cNvPr id="3" name="Shape 1"/>
+          <p:cNvSpPr/>
+          <p:nvPr/>
+        </p:nvSpPr>
+        <p:spPr>
+          <a:xfrm>
+            <a:off x="9601200" y="-2011680"/>
+            <a:ext cx="5029200" cy="5029200"/>
+          </a:xfrm>
+          <a:prstGeom prst="ellipse">
+            <a:avLst/>
+          </a:prstGeom>
+          <a:solidFill>
+            <a:srgbClr val="0F1A30"/>
+          </a:solidFill>
+          <a:ln w="12700">
+            <a:solidFill>
+              <a:srgbClr val="00A896"/>
+            </a:solidFill>
+            <a:prstDash val="solid"/>
+          </a:ln>
+        </p:spPr>
+      </p:sp>
+      <p:sp>
+        <p:nvSpPr>
+          <p:cNvPr id="4" name="Text 2"/>
+          <p:cNvSpPr/>
+          <p:nvPr/>
+        </p:nvSpPr>
+        <p:spPr>
+          <a:xfrm>
+            <a:off x="914400" y="1554480"/>
+            <a:ext cx="9144000" cy="365760"/>
+          </a:xfrm>
+          <a:prstGeom prst="rect">
+            <a:avLst/>
+          </a:prstGeom>
+          <a:noFill/>
+          <a:ln/>
+        </p:spPr>
+        <p:txBody>
+          <a:bodyPr wrap="square" lIns="0" tIns="0" rIns="0" bIns="0" rtlCol="0" anchor="ctr"/>
+          <a:lstStyle/>
+          <a:p>
+            <a:pPr indent="0" marL="0">
+              <a:buNone/>
+            </a:pPr>
+            <a:r>
+              <a:rPr lang="en-US" sz="1400" b="1" spc="300" kern="0" dirty="0">
+                <a:solidFill>
+                  <a:srgbClr val="02C39A"/>
+                </a:solidFill>
+                <a:latin typeface="Calibri" pitchFamily="34" charset="0"/>
+                <a:ea typeface="Calibri" pitchFamily="34" charset="-122"/>
+                <a:cs typeface="Calibri" pitchFamily="34" charset="-120"/>
+              </a:rPr>
+              <a:t>KEY TAKEAWAY</a:t>
+            </a:r>
+            <a:endParaRPr lang="en-US" sz="1400" dirty="0"/>
+          </a:p>
+        </p:txBody>
+      </p:sp>
+      <p:sp>
+        <p:nvSpPr>
+          <p:cNvPr id="5" name="Text 3"/>
+          <p:cNvSpPr/>
+          <p:nvPr/>
+        </p:nvSpPr>
+        <p:spPr>
+          <a:xfrm>
+            <a:off x="914400" y="1965960"/>
+            <a:ext cx="10424160" cy="1645920"/>
+          </a:xfrm>
+          <a:prstGeom prst="rect">
+            <a:avLst/>
+          </a:prstGeom>
+          <a:noFill/>
+          <a:ln/>
+        </p:spPr>
+        <p:txBody>
+          <a:bodyPr wrap="square" lIns="0" tIns="0" rIns="0" bIns="0" rtlCol="0" anchor="ctr"/>
+          <a:lstStyle/>
+          <a:p>
+            <a:pPr indent="0" marL="0">
+              <a:lnSpc>
+                <a:spcPct val="100000"/>
+              </a:lnSpc>
+              <a:buNone/>
+            </a:pPr>
+            <a:r>
+              <a:rPr lang="en-US" sz="3600" b="1" dirty="0">
+                <a:solidFill>
+                  <a:srgbClr val="EAF0F8"/>
+                </a:solidFill>
+                <a:latin typeface="Calibri" pitchFamily="34" charset="0"/>
+                <a:ea typeface="Calibri" pitchFamily="34" charset="-122"/>
+                <a:cs typeface="Calibri" pitchFamily="34" charset="-120"/>
+              </a:rPr>
+              <a:t>LangChain builds the pieces.</a:t>
+            </a:r>
+            <a:endParaRPr lang="en-US" sz="3600" dirty="0"/>
+          </a:p>
+          <a:p>
+            <a:pPr indent="0" marL="0">
+              <a:lnSpc>
+                <a:spcPct val="100000"/>
+              </a:lnSpc>
+              <a:buNone/>
+            </a:pPr>
+            <a:r>
+              <a:rPr lang="en-US" sz="3600" b="1" dirty="0">
+                <a:solidFill>
+                  <a:srgbClr val="EAF0F8"/>
+                </a:solidFill>
+                <a:latin typeface="Calibri" pitchFamily="34" charset="0"/>
+                <a:ea typeface="Calibri" pitchFamily="34" charset="-122"/>
+                <a:cs typeface="Calibri" pitchFamily="34" charset="-120"/>
+              </a:rPr>
+              <a:t>LangGraph makes them an agent.</a:t>
+            </a:r>
+            <a:endParaRPr lang="en-US" sz="3600" dirty="0"/>
+          </a:p>
+        </p:txBody>
+      </p:sp>
+      <p:sp>
+        <p:nvSpPr>
+          <p:cNvPr id="6" name="Shape 4"/>
+          <p:cNvSpPr/>
+          <p:nvPr/>
+        </p:nvSpPr>
+        <p:spPr>
+          <a:xfrm>
+            <a:off x="914400" y="3794760"/>
+            <a:ext cx="10332720" cy="1371600"/>
+          </a:xfrm>
+          <a:prstGeom prst="roundRect">
+            <a:avLst>
+              <a:gd name="adj" fmla="val 6667"/>
+            </a:avLst>
+          </a:prstGeom>
+          <a:solidFill>
+            <a:srgbClr val="16233F"/>
+          </a:solidFill>
+          <a:ln w="19050">
+            <a:solidFill>
+              <a:srgbClr val="02C39A"/>
+            </a:solidFill>
+            <a:prstDash val="solid"/>
+          </a:ln>
+          <a:effectLst>
+            <a:outerShdw sx="100000" sy="100000" kx="0" ky="0" algn="bl" rotWithShape="0" blurRad="101600" dist="38100" dir="5400000">
+              <a:srgbClr val="000000">
+                <a:alpha val="35000"/>
+              </a:srgbClr>
+            </a:outerShdw>
+          </a:effectLst>
+        </p:spPr>
+      </p:sp>
+      <p:sp>
+        <p:nvSpPr>
+          <p:cNvPr id="7" name="Text 5"/>
+          <p:cNvSpPr/>
+          <p:nvPr/>
+        </p:nvSpPr>
+        <p:spPr>
+          <a:xfrm>
+            <a:off x="1188720" y="3977640"/>
+            <a:ext cx="9784080" cy="457200"/>
+          </a:xfrm>
+          <a:prstGeom prst="rect">
+            <a:avLst/>
+          </a:prstGeom>
+          <a:noFill/>
+          <a:ln/>
+        </p:spPr>
+        <p:txBody>
+          <a:bodyPr wrap="square" lIns="0" tIns="0" rIns="0" bIns="0" rtlCol="0" anchor="ctr"/>
+          <a:lstStyle/>
+          <a:p>
+            <a:pPr indent="0" marL="0">
+              <a:buNone/>
+            </a:pPr>
+            <a:r>
+              <a:rPr lang="en-US" sz="1800" b="1" dirty="0">
+                <a:solidFill>
+                  <a:srgbClr val="EAF0F8"/>
+                </a:solidFill>
+                <a:latin typeface="Calibri" pitchFamily="34" charset="0"/>
+                <a:ea typeface="Calibri" pitchFamily="34" charset="-122"/>
+                <a:cs typeface="Calibri" pitchFamily="34" charset="-120"/>
+              </a:rPr>
+              <a:t>Chains flow one way; agents loop, remember, branch, and pause for you.</a:t>
+            </a:r>
+            <a:endParaRPr lang="en-US" sz="1800" dirty="0"/>
+          </a:p>
+        </p:txBody>
+      </p:sp>
+      <p:sp>
+        <p:nvSpPr>
+          <p:cNvPr id="8" name="Text 6"/>
+          <p:cNvSpPr/>
+          <p:nvPr/>
+        </p:nvSpPr>
+        <p:spPr>
+          <a:xfrm>
+            <a:off x="1188720" y="4526280"/>
+            <a:ext cx="9784080" cy="457200"/>
+          </a:xfrm>
+          <a:prstGeom prst="rect">
+            <a:avLst/>
+          </a:prstGeom>
+          <a:noFill/>
+          <a:ln/>
+        </p:spPr>
+        <p:txBody>
+          <a:bodyPr wrap="square" lIns="0" tIns="0" rIns="0" bIns="0" rtlCol="0" anchor="ctr"/>
+          <a:lstStyle/>
+          <a:p>
+            <a:pPr indent="0" marL="0">
+              <a:buNone/>
+            </a:pPr>
+            <a:r>
+              <a:rPr lang="en-US" sz="1450" i="1" dirty="0">
+                <a:solidFill>
+                  <a:srgbClr val="00A896"/>
+                </a:solidFill>
+                <a:latin typeface="Calibri" pitchFamily="34" charset="0"/>
+                <a:ea typeface="Calibri" pitchFamily="34" charset="-122"/>
+                <a:cs typeface="Calibri" pitchFamily="34" charset="-120"/>
+              </a:rPr>
+              <a:t>You now have both — plus the notebooks to keep building.</a:t>
+            </a:r>
+            <a:endParaRPr lang="en-US" sz="1450" dirty="0"/>
+          </a:p>
+        </p:txBody>
+      </p:sp>
+      <p:sp>
+        <p:nvSpPr>
+          <p:cNvPr id="9" name="Text 7"/>
+          <p:cNvSpPr/>
+          <p:nvPr/>
+        </p:nvSpPr>
+        <p:spPr>
+          <a:xfrm>
+            <a:off x="914400" y="5532120"/>
+            <a:ext cx="5486400" cy="457200"/>
+          </a:xfrm>
+          <a:prstGeom prst="rect">
+            <a:avLst/>
+          </a:prstGeom>
+          <a:noFill/>
+          <a:ln/>
+        </p:spPr>
+        <p:txBody>
+          <a:bodyPr wrap="square" lIns="0" tIns="0" rIns="0" bIns="0" rtlCol="0" anchor="ctr"/>
+          <a:lstStyle/>
+          <a:p>
+            <a:pPr indent="0" marL="0">
+              <a:buNone/>
+            </a:pPr>
+            <a:r>
+              <a:rPr lang="en-US" sz="2200" b="1" dirty="0">
+                <a:solidFill>
+                  <a:srgbClr val="02C39A"/>
+                </a:solidFill>
+                <a:latin typeface="Calibri" pitchFamily="34" charset="0"/>
+                <a:ea typeface="Calibri" pitchFamily="34" charset="-122"/>
+                <a:cs typeface="Calibri" pitchFamily="34" charset="-120"/>
+              </a:rPr>
+              <a:t>Questions?</a:t>
+            </a:r>
+            <a:endParaRPr lang="en-US" sz="2200" dirty="0"/>
+          </a:p>
+        </p:txBody>
+      </p:sp>
+    </p:spTree>
+  </p:cSld>
+  <p:clrMapOvr>
+    <a:masterClrMapping/>
+  </p:clrMapOvr>
+</p:sld>
+</file>
+
 <file path=ppt/slides/slide2.xml><?xml version="1.0" encoding="utf-8"?>
 <p:sld xmlns:a="http://schemas.openxmlformats.org/drawingml/2006/main" xmlns:r="http://schemas.openxmlformats.org/officeDocument/2006/relationships" xmlns:p="http://schemas.openxmlformats.org/presentationml/2006/main">
   <p:cSld name="Slide 2">
@@ -7749,7 +8172,7 @@
                 <a:ea typeface="Calibri" pitchFamily="34" charset="-122"/>
                 <a:cs typeface="Calibri" pitchFamily="34" charset="-120"/>
               </a:rPr>
-              <a:t>YOUR TURN</a:t>
+              <a:t>SEE IT RUN</a:t>
             </a:r>
             <a:endParaRPr lang="en-US" sz="1200" dirty="0"/>
           </a:p>
@@ -7788,7 +8211,7 @@
                 <a:ea typeface="Calibri" pitchFamily="34" charset="-122"/>
                 <a:cs typeface="Calibri" pitchFamily="34" charset="-120"/>
               </a:rPr>
-              <a:t>What you'll run</a:t>
+              <a:t>LangGraph Studio</a:t>
             </a:r>
             <a:endParaRPr lang="en-US" sz="3400" dirty="0"/>
           </a:p>
@@ -7802,380 +8225,12 @@
         </p:nvSpPr>
         <p:spPr>
           <a:xfrm>
-            <a:off x="640080" y="1920240"/>
-            <a:ext cx="5303520" cy="3566160"/>
+            <a:off x="493776" y="1545336"/>
+            <a:ext cx="6876288" cy="4602050"/>
           </a:xfrm>
           <a:prstGeom prst="roundRect">
             <a:avLst>
-              <a:gd name="adj" fmla="val 2051"/>
-            </a:avLst>
-          </a:prstGeom>
-          <a:solidFill>
-            <a:srgbClr val="16233F"/>
-          </a:solidFill>
-          <a:ln w="19050">
-            <a:solidFill>
-              <a:srgbClr val="02C39A"/>
-            </a:solidFill>
-            <a:prstDash val="solid"/>
-          </a:ln>
-          <a:effectLst>
-            <a:outerShdw sx="100000" sy="100000" kx="0" ky="0" algn="bl" rotWithShape="0" blurRad="101600" dist="38100" dir="5400000">
-              <a:srgbClr val="000000">
-                <a:alpha val="35000"/>
-              </a:srgbClr>
-            </a:outerShdw>
-          </a:effectLst>
-        </p:spPr>
-      </p:sp>
-      <p:sp>
-        <p:nvSpPr>
-          <p:cNvPr id="5" name="Text 3"/>
-          <p:cNvSpPr/>
-          <p:nvPr/>
-        </p:nvSpPr>
-        <p:spPr>
-          <a:xfrm>
-            <a:off x="960120" y="2148840"/>
-            <a:ext cx="4572000" cy="274320"/>
-          </a:xfrm>
-          <a:prstGeom prst="rect">
-            <a:avLst/>
-          </a:prstGeom>
-          <a:noFill/>
-          <a:ln/>
-        </p:spPr>
-        <p:txBody>
-          <a:bodyPr wrap="square" lIns="0" tIns="0" rIns="0" bIns="0" rtlCol="0" anchor="ctr"/>
-          <a:lstStyle/>
-          <a:p>
-            <a:pPr indent="0" marL="0">
-              <a:buNone/>
-            </a:pPr>
-            <a:r>
-              <a:rPr lang="en-US" sz="1100" b="1" spc="200" kern="0" dirty="0">
-                <a:solidFill>
-                  <a:srgbClr val="02C39A"/>
-                </a:solidFill>
-                <a:latin typeface="Calibri" pitchFamily="34" charset="0"/>
-                <a:ea typeface="Calibri" pitchFamily="34" charset="-122"/>
-                <a:cs typeface="Calibri" pitchFamily="34" charset="-120"/>
-              </a:rPr>
-              <a:t>NOTEBOOK 01</a:t>
-            </a:r>
-            <a:endParaRPr lang="en-US" sz="1100" dirty="0"/>
-          </a:p>
-        </p:txBody>
-      </p:sp>
-      <p:sp>
-        <p:nvSpPr>
-          <p:cNvPr id="6" name="Text 4"/>
-          <p:cNvSpPr/>
-          <p:nvPr/>
-        </p:nvSpPr>
-        <p:spPr>
-          <a:xfrm>
-            <a:off x="960120" y="2423160"/>
-            <a:ext cx="4572000" cy="548640"/>
-          </a:xfrm>
-          <a:prstGeom prst="rect">
-            <a:avLst/>
-          </a:prstGeom>
-          <a:noFill/>
-          <a:ln/>
-        </p:spPr>
-        <p:txBody>
-          <a:bodyPr wrap="square" lIns="0" tIns="0" rIns="0" bIns="0" rtlCol="0" anchor="ctr"/>
-          <a:lstStyle/>
-          <a:p>
-            <a:pPr indent="0" marL="0">
-              <a:buNone/>
-            </a:pPr>
-            <a:r>
-              <a:rPr lang="en-US" sz="2400" b="1" dirty="0">
-                <a:solidFill>
-                  <a:srgbClr val="EAF0F8"/>
-                </a:solidFill>
-                <a:latin typeface="Calibri" pitchFamily="34" charset="0"/>
-                <a:ea typeface="Calibri" pitchFamily="34" charset="-122"/>
-                <a:cs typeface="Calibri" pitchFamily="34" charset="-120"/>
-              </a:rPr>
-              <a:t>LangChain</a:t>
-            </a:r>
-            <a:endParaRPr lang="en-US" sz="2400" dirty="0"/>
-          </a:p>
-        </p:txBody>
-      </p:sp>
-      <p:sp>
-        <p:nvSpPr>
-          <p:cNvPr id="7" name="Shape 5"/>
-          <p:cNvSpPr/>
-          <p:nvPr/>
-        </p:nvSpPr>
-        <p:spPr>
-          <a:xfrm>
-            <a:off x="1005840" y="3264408"/>
-            <a:ext cx="109728" cy="109728"/>
-          </a:xfrm>
-          <a:prstGeom prst="ellipse">
-            <a:avLst/>
-          </a:prstGeom>
-          <a:solidFill>
-            <a:srgbClr val="02C39A"/>
-          </a:solidFill>
-          <a:ln w="12700">
-            <a:solidFill>
-              <a:srgbClr val="02C39A"/>
-            </a:solidFill>
-            <a:prstDash val="solid"/>
-          </a:ln>
-        </p:spPr>
-      </p:sp>
-      <p:sp>
-        <p:nvSpPr>
-          <p:cNvPr id="8" name="Text 6"/>
-          <p:cNvSpPr/>
-          <p:nvPr/>
-        </p:nvSpPr>
-        <p:spPr>
-          <a:xfrm>
-            <a:off x="1234440" y="3145536"/>
-            <a:ext cx="4480560" cy="457200"/>
-          </a:xfrm>
-          <a:prstGeom prst="rect">
-            <a:avLst/>
-          </a:prstGeom>
-          <a:noFill/>
-          <a:ln/>
-        </p:spPr>
-        <p:txBody>
-          <a:bodyPr wrap="square" lIns="0" tIns="0" rIns="0" bIns="0" rtlCol="0" anchor="t"/>
-          <a:lstStyle/>
-          <a:p>
-            <a:pPr indent="0" marL="0">
-              <a:buNone/>
-            </a:pPr>
-            <a:r>
-              <a:rPr lang="en-US" sz="1400" dirty="0">
-                <a:solidFill>
-                  <a:srgbClr val="EAF0F8"/>
-                </a:solidFill>
-                <a:latin typeface="Calibri" pitchFamily="34" charset="0"/>
-                <a:ea typeface="Calibri" pitchFamily="34" charset="-122"/>
-                <a:cs typeface="Calibri" pitchFamily="34" charset="-120"/>
-              </a:rPr>
-              <a:t>LCEL chain</a:t>
-            </a:r>
-            <a:endParaRPr lang="en-US" sz="1400" dirty="0"/>
-          </a:p>
-        </p:txBody>
-      </p:sp>
-      <p:sp>
-        <p:nvSpPr>
-          <p:cNvPr id="9" name="Shape 7"/>
-          <p:cNvSpPr/>
-          <p:nvPr/>
-        </p:nvSpPr>
-        <p:spPr>
-          <a:xfrm>
-            <a:off x="1005840" y="3794760"/>
-            <a:ext cx="109728" cy="109728"/>
-          </a:xfrm>
-          <a:prstGeom prst="ellipse">
-            <a:avLst/>
-          </a:prstGeom>
-          <a:solidFill>
-            <a:srgbClr val="02C39A"/>
-          </a:solidFill>
-          <a:ln w="12700">
-            <a:solidFill>
-              <a:srgbClr val="02C39A"/>
-            </a:solidFill>
-            <a:prstDash val="solid"/>
-          </a:ln>
-        </p:spPr>
-      </p:sp>
-      <p:sp>
-        <p:nvSpPr>
-          <p:cNvPr id="10" name="Text 8"/>
-          <p:cNvSpPr/>
-          <p:nvPr/>
-        </p:nvSpPr>
-        <p:spPr>
-          <a:xfrm>
-            <a:off x="1234440" y="3675888"/>
-            <a:ext cx="4480560" cy="457200"/>
-          </a:xfrm>
-          <a:prstGeom prst="rect">
-            <a:avLst/>
-          </a:prstGeom>
-          <a:noFill/>
-          <a:ln/>
-        </p:spPr>
-        <p:txBody>
-          <a:bodyPr wrap="square" lIns="0" tIns="0" rIns="0" bIns="0" rtlCol="0" anchor="t"/>
-          <a:lstStyle/>
-          <a:p>
-            <a:pPr indent="0" marL="0">
-              <a:buNone/>
-            </a:pPr>
-            <a:r>
-              <a:rPr lang="en-US" sz="1400" dirty="0">
-                <a:solidFill>
-                  <a:srgbClr val="EAF0F8"/>
-                </a:solidFill>
-                <a:latin typeface="Calibri" pitchFamily="34" charset="0"/>
-                <a:ea typeface="Calibri" pitchFamily="34" charset="-122"/>
-                <a:cs typeface="Calibri" pitchFamily="34" charset="-120"/>
-              </a:rPr>
-              <a:t>tool calling + closing the loop</a:t>
-            </a:r>
-            <a:endParaRPr lang="en-US" sz="1400" dirty="0"/>
-          </a:p>
-        </p:txBody>
-      </p:sp>
-      <p:sp>
-        <p:nvSpPr>
-          <p:cNvPr id="11" name="Shape 9"/>
-          <p:cNvSpPr/>
-          <p:nvPr/>
-        </p:nvSpPr>
-        <p:spPr>
-          <a:xfrm>
-            <a:off x="1005840" y="4325112"/>
-            <a:ext cx="109728" cy="109728"/>
-          </a:xfrm>
-          <a:prstGeom prst="ellipse">
-            <a:avLst/>
-          </a:prstGeom>
-          <a:solidFill>
-            <a:srgbClr val="02C39A"/>
-          </a:solidFill>
-          <a:ln w="12700">
-            <a:solidFill>
-              <a:srgbClr val="02C39A"/>
-            </a:solidFill>
-            <a:prstDash val="solid"/>
-          </a:ln>
-        </p:spPr>
-      </p:sp>
-      <p:sp>
-        <p:nvSpPr>
-          <p:cNvPr id="12" name="Text 10"/>
-          <p:cNvSpPr/>
-          <p:nvPr/>
-        </p:nvSpPr>
-        <p:spPr>
-          <a:xfrm>
-            <a:off x="1234440" y="4206240"/>
-            <a:ext cx="4480560" cy="457200"/>
-          </a:xfrm>
-          <a:prstGeom prst="rect">
-            <a:avLst/>
-          </a:prstGeom>
-          <a:noFill/>
-          <a:ln/>
-        </p:spPr>
-        <p:txBody>
-          <a:bodyPr wrap="square" lIns="0" tIns="0" rIns="0" bIns="0" rtlCol="0" anchor="t"/>
-          <a:lstStyle/>
-          <a:p>
-            <a:pPr indent="0" marL="0">
-              <a:buNone/>
-            </a:pPr>
-            <a:r>
-              <a:rPr lang="en-US" sz="1400" dirty="0">
-                <a:solidFill>
-                  <a:srgbClr val="EAF0F8"/>
-                </a:solidFill>
-                <a:latin typeface="Calibri" pitchFamily="34" charset="0"/>
-                <a:ea typeface="Calibri" pitchFamily="34" charset="-122"/>
-                <a:cs typeface="Calibri" pitchFamily="34" charset="-120"/>
-              </a:rPr>
-              <a:t>streaming</a:t>
-            </a:r>
-            <a:endParaRPr lang="en-US" sz="1400" dirty="0"/>
-          </a:p>
-        </p:txBody>
-      </p:sp>
-      <p:sp>
-        <p:nvSpPr>
-          <p:cNvPr id="13" name="Shape 11"/>
-          <p:cNvSpPr/>
-          <p:nvPr/>
-        </p:nvSpPr>
-        <p:spPr>
-          <a:xfrm>
-            <a:off x="1005840" y="4855464"/>
-            <a:ext cx="109728" cy="109728"/>
-          </a:xfrm>
-          <a:prstGeom prst="ellipse">
-            <a:avLst/>
-          </a:prstGeom>
-          <a:solidFill>
-            <a:srgbClr val="02C39A"/>
-          </a:solidFill>
-          <a:ln w="12700">
-            <a:solidFill>
-              <a:srgbClr val="02C39A"/>
-            </a:solidFill>
-            <a:prstDash val="solid"/>
-          </a:ln>
-        </p:spPr>
-      </p:sp>
-      <p:sp>
-        <p:nvSpPr>
-          <p:cNvPr id="14" name="Text 12"/>
-          <p:cNvSpPr/>
-          <p:nvPr/>
-        </p:nvSpPr>
-        <p:spPr>
-          <a:xfrm>
-            <a:off x="1234440" y="4736592"/>
-            <a:ext cx="4480560" cy="457200"/>
-          </a:xfrm>
-          <a:prstGeom prst="rect">
-            <a:avLst/>
-          </a:prstGeom>
-          <a:noFill/>
-          <a:ln/>
-        </p:spPr>
-        <p:txBody>
-          <a:bodyPr wrap="square" lIns="0" tIns="0" rIns="0" bIns="0" rtlCol="0" anchor="t"/>
-          <a:lstStyle/>
-          <a:p>
-            <a:pPr indent="0" marL="0">
-              <a:buNone/>
-            </a:pPr>
-            <a:r>
-              <a:rPr lang="en-US" sz="1400" dirty="0">
-                <a:solidFill>
-                  <a:srgbClr val="EAF0F8"/>
-                </a:solidFill>
-                <a:latin typeface="Calibri" pitchFamily="34" charset="0"/>
-                <a:ea typeface="Calibri" pitchFamily="34" charset="-122"/>
-                <a:cs typeface="Calibri" pitchFamily="34" charset="-120"/>
-              </a:rPr>
-              <a:t>🧪 add a 2nd tool</a:t>
-            </a:r>
-            <a:endParaRPr lang="en-US" sz="1400" dirty="0"/>
-          </a:p>
-        </p:txBody>
-      </p:sp>
-      <p:sp>
-        <p:nvSpPr>
-          <p:cNvPr id="15" name="Shape 13"/>
-          <p:cNvSpPr/>
-          <p:nvPr/>
-        </p:nvSpPr>
-        <p:spPr>
-          <a:xfrm>
-            <a:off x="6245352" y="1920240"/>
-            <a:ext cx="5303520" cy="3566160"/>
-          </a:xfrm>
-          <a:prstGeom prst="roundRect">
-            <a:avLst>
-              <a:gd name="adj" fmla="val 2051"/>
+              <a:gd name="adj" fmla="val 1192"/>
             </a:avLst>
           </a:prstGeom>
           <a:solidFill>
@@ -8196,104 +8251,50 @@
           </a:effectLst>
         </p:spPr>
       </p:sp>
-      <p:sp>
-        <p:nvSpPr>
-          <p:cNvPr id="16" name="Text 14"/>
-          <p:cNvSpPr/>
-          <p:nvPr/>
-        </p:nvSpPr>
-        <p:spPr>
-          <a:xfrm>
-            <a:off x="6565392" y="2148840"/>
-            <a:ext cx="4572000" cy="274320"/>
-          </a:xfrm>
-          <a:prstGeom prst="rect">
-            <a:avLst/>
-          </a:prstGeom>
-          <a:noFill/>
-          <a:ln/>
-        </p:spPr>
-        <p:txBody>
-          <a:bodyPr wrap="square" lIns="0" tIns="0" rIns="0" bIns="0" rtlCol="0" anchor="ctr"/>
-          <a:lstStyle/>
-          <a:p>
-            <a:pPr indent="0" marL="0">
-              <a:buNone/>
-            </a:pPr>
-            <a:r>
-              <a:rPr lang="en-US" sz="1100" b="1" spc="200" kern="0" dirty="0">
-                <a:solidFill>
-                  <a:srgbClr val="00A896"/>
-                </a:solidFill>
-                <a:latin typeface="Calibri" pitchFamily="34" charset="0"/>
-                <a:ea typeface="Calibri" pitchFamily="34" charset="-122"/>
-                <a:cs typeface="Calibri" pitchFamily="34" charset="-120"/>
-              </a:rPr>
-              <a:t>NOTEBOOK 02</a:t>
-            </a:r>
-            <a:endParaRPr lang="en-US" sz="1100" dirty="0"/>
-          </a:p>
-        </p:txBody>
-      </p:sp>
-      <p:sp>
-        <p:nvSpPr>
-          <p:cNvPr id="17" name="Text 15"/>
-          <p:cNvSpPr/>
-          <p:nvPr/>
-        </p:nvSpPr>
-        <p:spPr>
-          <a:xfrm>
-            <a:off x="6565392" y="2423160"/>
-            <a:ext cx="4572000" cy="548640"/>
-          </a:xfrm>
-          <a:prstGeom prst="rect">
-            <a:avLst/>
-          </a:prstGeom>
-          <a:noFill/>
-          <a:ln/>
-        </p:spPr>
-        <p:txBody>
-          <a:bodyPr wrap="square" lIns="0" tIns="0" rIns="0" bIns="0" rtlCol="0" anchor="ctr"/>
-          <a:lstStyle/>
-          <a:p>
-            <a:pPr indent="0" marL="0">
-              <a:buNone/>
-            </a:pPr>
-            <a:r>
-              <a:rPr lang="en-US" sz="2400" b="1" dirty="0">
-                <a:solidFill>
-                  <a:srgbClr val="EAF0F8"/>
-                </a:solidFill>
-                <a:latin typeface="Calibri" pitchFamily="34" charset="0"/>
-                <a:ea typeface="Calibri" pitchFamily="34" charset="-122"/>
-                <a:cs typeface="Calibri" pitchFamily="34" charset="-120"/>
-              </a:rPr>
-              <a:t>LangGraph</a:t>
-            </a:r>
-            <a:endParaRPr lang="en-US" sz="2400" dirty="0"/>
-          </a:p>
-        </p:txBody>
-      </p:sp>
-      <p:sp>
-        <p:nvSpPr>
-          <p:cNvPr id="18" name="Shape 16"/>
-          <p:cNvSpPr/>
-          <p:nvPr/>
-        </p:nvSpPr>
-        <p:spPr>
-          <a:xfrm>
-            <a:off x="6611112" y="3264408"/>
-            <a:ext cx="109728" cy="109728"/>
+      <p:pic>
+        <p:nvPicPr>
+          <p:cNvPr id="5" name="Image 0" descr="/Users/nomithar_500053/Desktop/Modern AI Stack/assets/langgraph_studio.png">    </p:cNvPr>
+          <p:cNvPicPr>
+            <a:picLocks noChangeAspect="1"/>
+          </p:cNvPicPr>
+          <p:nvPr/>
+        </p:nvPicPr>
+        <p:blipFill>
+          <a:blip r:embed="rId1"/>
+          <a:stretch>
+            <a:fillRect/>
+          </a:stretch>
+        </p:blipFill>
+        <p:spPr>
+          <a:xfrm>
+            <a:off x="548640" y="1600200"/>
+            <a:ext cx="6766560" cy="4492322"/>
+          </a:xfrm>
+          <a:prstGeom prst="rect">
+            <a:avLst/>
+          </a:prstGeom>
+        </p:spPr>
+      </p:pic>
+      <p:sp>
+        <p:nvSpPr>
+          <p:cNvPr id="6" name="Shape 3"/>
+          <p:cNvSpPr/>
+          <p:nvPr/>
+        </p:nvSpPr>
+        <p:spPr>
+          <a:xfrm>
+            <a:off x="7635240" y="1810512"/>
+            <a:ext cx="347472" cy="347472"/>
           </a:xfrm>
           <a:prstGeom prst="ellipse">
             <a:avLst/>
           </a:prstGeom>
           <a:solidFill>
-            <a:srgbClr val="00A896"/>
+            <a:srgbClr val="16233F"/>
           </a:solidFill>
-          <a:ln w="12700">
+          <a:ln w="19050">
             <a:solidFill>
-              <a:srgbClr val="00A896"/>
+              <a:srgbClr val="02C39A"/>
             </a:solidFill>
             <a:prstDash val="solid"/>
           </a:ln>
@@ -8301,14 +8302,53 @@
       </p:sp>
       <p:sp>
         <p:nvSpPr>
-          <p:cNvPr id="19" name="Text 17"/>
-          <p:cNvSpPr/>
-          <p:nvPr/>
-        </p:nvSpPr>
-        <p:spPr>
-          <a:xfrm>
-            <a:off x="6839712" y="3145536"/>
-            <a:ext cx="4480560" cy="457200"/>
+          <p:cNvPr id="7" name="Text 4"/>
+          <p:cNvSpPr/>
+          <p:nvPr/>
+        </p:nvSpPr>
+        <p:spPr>
+          <a:xfrm>
+            <a:off x="7635240" y="1810512"/>
+            <a:ext cx="347472" cy="347472"/>
+          </a:xfrm>
+          <a:prstGeom prst="rect">
+            <a:avLst/>
+          </a:prstGeom>
+          <a:noFill/>
+          <a:ln/>
+        </p:spPr>
+        <p:txBody>
+          <a:bodyPr wrap="square" lIns="0" tIns="0" rIns="0" bIns="0" rtlCol="0" anchor="ctr"/>
+          <a:lstStyle/>
+          <a:p>
+            <a:pPr algn="ctr" indent="0" marL="0">
+              <a:buNone/>
+            </a:pPr>
+            <a:r>
+              <a:rPr lang="en-US" sz="1300" b="1" dirty="0">
+                <a:solidFill>
+                  <a:srgbClr val="02C39A"/>
+                </a:solidFill>
+                <a:latin typeface="Calibri" pitchFamily="34" charset="0"/>
+                <a:ea typeface="Calibri" pitchFamily="34" charset="-122"/>
+                <a:cs typeface="Calibri" pitchFamily="34" charset="-120"/>
+              </a:rPr>
+              <a:t>1</a:t>
+            </a:r>
+            <a:endParaRPr lang="en-US" sz="1300" dirty="0"/>
+          </a:p>
+        </p:txBody>
+      </p:sp>
+      <p:sp>
+        <p:nvSpPr>
+          <p:cNvPr id="8" name="Text 5"/>
+          <p:cNvSpPr/>
+          <p:nvPr/>
+        </p:nvSpPr>
+        <p:spPr>
+          <a:xfrm>
+            <a:off x="8092440" y="1746504"/>
+            <a:ext cx="3429000" cy="914400"/>
           </a:xfrm>
           <a:prstGeom prst="rect">
             <a:avLst/>
@@ -8321,10 +8361,13 @@
           <a:lstStyle/>
           <a:p>
             <a:pPr indent="0" marL="0">
-              <a:buNone/>
-            </a:pPr>
-            <a:r>
-              <a:rPr lang="en-US" sz="1400" dirty="0">
+              <a:lnSpc>
+                <a:spcPct val="100000"/>
+              </a:lnSpc>
+              <a:buNone/>
+            </a:pPr>
+            <a:r>
+              <a:rPr lang="en-US" sz="1250" b="1" dirty="0">
                 <a:solidFill>
                   <a:srgbClr val="EAF0F8"/>
                 </a:solidFill>
@@ -8332,32 +8375,58 @@
                 <a:ea typeface="Calibri" pitchFamily="34" charset="-122"/>
                 <a:cs typeface="Calibri" pitchFamily="34" charset="-120"/>
               </a:rPr>
-              <a:t>state graph from scratch</a:t>
-            </a:r>
-            <a:endParaRPr lang="en-US" sz="1400" dirty="0"/>
-          </a:p>
-        </p:txBody>
-      </p:sp>
-      <p:sp>
-        <p:nvSpPr>
-          <p:cNvPr id="20" name="Shape 18"/>
-          <p:cNvSpPr/>
-          <p:nvPr/>
-        </p:nvSpPr>
-        <p:spPr>
-          <a:xfrm>
-            <a:off x="6611112" y="3794760"/>
-            <a:ext cx="109728" cy="109728"/>
+              <a:t>The graph, live</a:t>
+            </a:r>
+            <a:pPr indent="0" marL="0">
+              <a:lnSpc>
+                <a:spcPct val="100000"/>
+              </a:lnSpc>
+              <a:buNone/>
+            </a:pPr>
+            <a:endParaRPr lang="en-US" sz="1250" dirty="0"/>
+          </a:p>
+          <a:p>
+            <a:pPr indent="0" marL="0">
+              <a:lnSpc>
+                <a:spcPct val="100000"/>
+              </a:lnSpc>
+              <a:buNone/>
+            </a:pPr>
+            <a:r>
+              <a:rPr lang="en-US" sz="1250" dirty="0">
+                <a:solidFill>
+                  <a:srgbClr val="9AAAC4"/>
+                </a:solidFill>
+                <a:latin typeface="Calibri" pitchFamily="34" charset="0"/>
+                <a:ea typeface="Calibri" pitchFamily="34" charset="-122"/>
+                <a:cs typeface="Calibri" pitchFamily="34" charset="-120"/>
+              </a:rPr>
+              <a:t>nodes, edges, and the loop — rendered from your code</a:t>
+            </a:r>
+            <a:endParaRPr lang="en-US" sz="1250" dirty="0"/>
+          </a:p>
+        </p:txBody>
+      </p:sp>
+      <p:sp>
+        <p:nvSpPr>
+          <p:cNvPr id="9" name="Shape 6"/>
+          <p:cNvSpPr/>
+          <p:nvPr/>
+        </p:nvSpPr>
+        <p:spPr>
+          <a:xfrm>
+            <a:off x="7635240" y="2834640"/>
+            <a:ext cx="347472" cy="347472"/>
           </a:xfrm>
           <a:prstGeom prst="ellipse">
             <a:avLst/>
           </a:prstGeom>
           <a:solidFill>
-            <a:srgbClr val="00A896"/>
+            <a:srgbClr val="16233F"/>
           </a:solidFill>
-          <a:ln w="12700">
+          <a:ln w="19050">
             <a:solidFill>
-              <a:srgbClr val="00A896"/>
+              <a:srgbClr val="02C39A"/>
             </a:solidFill>
             <a:prstDash val="solid"/>
           </a:ln>
@@ -8365,14 +8434,53 @@
       </p:sp>
       <p:sp>
         <p:nvSpPr>
-          <p:cNvPr id="21" name="Text 19"/>
-          <p:cNvSpPr/>
-          <p:nvPr/>
-        </p:nvSpPr>
-        <p:spPr>
-          <a:xfrm>
-            <a:off x="6839712" y="3675888"/>
-            <a:ext cx="4480560" cy="457200"/>
+          <p:cNvPr id="10" name="Text 7"/>
+          <p:cNvSpPr/>
+          <p:nvPr/>
+        </p:nvSpPr>
+        <p:spPr>
+          <a:xfrm>
+            <a:off x="7635240" y="2834640"/>
+            <a:ext cx="347472" cy="347472"/>
+          </a:xfrm>
+          <a:prstGeom prst="rect">
+            <a:avLst/>
+          </a:prstGeom>
+          <a:noFill/>
+          <a:ln/>
+        </p:spPr>
+        <p:txBody>
+          <a:bodyPr wrap="square" lIns="0" tIns="0" rIns="0" bIns="0" rtlCol="0" anchor="ctr"/>
+          <a:lstStyle/>
+          <a:p>
+            <a:pPr algn="ctr" indent="0" marL="0">
+              <a:buNone/>
+            </a:pPr>
+            <a:r>
+              <a:rPr lang="en-US" sz="1300" b="1" dirty="0">
+                <a:solidFill>
+                  <a:srgbClr val="02C39A"/>
+                </a:solidFill>
+                <a:latin typeface="Calibri" pitchFamily="34" charset="0"/>
+                <a:ea typeface="Calibri" pitchFamily="34" charset="-122"/>
+                <a:cs typeface="Calibri" pitchFamily="34" charset="-120"/>
+              </a:rPr>
+              <a:t>2</a:t>
+            </a:r>
+            <a:endParaRPr lang="en-US" sz="1300" dirty="0"/>
+          </a:p>
+        </p:txBody>
+      </p:sp>
+      <p:sp>
+        <p:nvSpPr>
+          <p:cNvPr id="11" name="Text 8"/>
+          <p:cNvSpPr/>
+          <p:nvPr/>
+        </p:nvSpPr>
+        <p:spPr>
+          <a:xfrm>
+            <a:off x="8092440" y="2770632"/>
+            <a:ext cx="3429000" cy="914400"/>
           </a:xfrm>
           <a:prstGeom prst="rect">
             <a:avLst/>
@@ -8385,10 +8493,13 @@
           <a:lstStyle/>
           <a:p>
             <a:pPr indent="0" marL="0">
-              <a:buNone/>
-            </a:pPr>
-            <a:r>
-              <a:rPr lang="en-US" sz="1400" dirty="0">
+              <a:lnSpc>
+                <a:spcPct val="100000"/>
+              </a:lnSpc>
+              <a:buNone/>
+            </a:pPr>
+            <a:r>
+              <a:rPr lang="en-US" sz="1250" b="1" dirty="0">
                 <a:solidFill>
                   <a:srgbClr val="EAF0F8"/>
                 </a:solidFill>
@@ -8396,32 +8507,58 @@
                 <a:ea typeface="Calibri" pitchFamily="34" charset="-122"/>
                 <a:cs typeface="Calibri" pitchFamily="34" charset="-120"/>
               </a:rPr>
-              <a:t>conditional edges</a:t>
-            </a:r>
-            <a:endParaRPr lang="en-US" sz="1400" dirty="0"/>
-          </a:p>
-        </p:txBody>
-      </p:sp>
-      <p:sp>
-        <p:nvSpPr>
-          <p:cNvPr id="22" name="Shape 20"/>
-          <p:cNvSpPr/>
-          <p:nvPr/>
-        </p:nvSpPr>
-        <p:spPr>
-          <a:xfrm>
-            <a:off x="6611112" y="4325112"/>
-            <a:ext cx="109728" cy="109728"/>
+              <a:t>Thread panel</a:t>
+            </a:r>
+            <a:pPr indent="0" marL="0">
+              <a:lnSpc>
+                <a:spcPct val="100000"/>
+              </a:lnSpc>
+              <a:buNone/>
+            </a:pPr>
+            <a:endParaRPr lang="en-US" sz="1250" dirty="0"/>
+          </a:p>
+          <a:p>
+            <a:pPr indent="0" marL="0">
+              <a:lnSpc>
+                <a:spcPct val="100000"/>
+              </a:lnSpc>
+              <a:buNone/>
+            </a:pPr>
+            <a:r>
+              <a:rPr lang="en-US" sz="1250" dirty="0">
+                <a:solidFill>
+                  <a:srgbClr val="9AAAC4"/>
+                </a:solidFill>
+                <a:latin typeface="Calibri" pitchFamily="34" charset="0"/>
+                <a:ea typeface="Calibri" pitchFamily="34" charset="-122"/>
+                <a:cs typeface="Calibri" pitchFamily="34" charset="-120"/>
+              </a:rPr>
+              <a:t>messages, state, and the model's output side-by-side</a:t>
+            </a:r>
+            <a:endParaRPr lang="en-US" sz="1250" dirty="0"/>
+          </a:p>
+        </p:txBody>
+      </p:sp>
+      <p:sp>
+        <p:nvSpPr>
+          <p:cNvPr id="12" name="Shape 9"/>
+          <p:cNvSpPr/>
+          <p:nvPr/>
+        </p:nvSpPr>
+        <p:spPr>
+          <a:xfrm>
+            <a:off x="7635240" y="3858768"/>
+            <a:ext cx="347472" cy="347472"/>
           </a:xfrm>
           <a:prstGeom prst="ellipse">
             <a:avLst/>
           </a:prstGeom>
           <a:solidFill>
-            <a:srgbClr val="00A896"/>
+            <a:srgbClr val="16233F"/>
           </a:solidFill>
-          <a:ln w="12700">
+          <a:ln w="19050">
             <a:solidFill>
-              <a:srgbClr val="00A896"/>
+              <a:srgbClr val="02C39A"/>
             </a:solidFill>
             <a:prstDash val="solid"/>
           </a:ln>
@@ -8429,14 +8566,53 @@
       </p:sp>
       <p:sp>
         <p:nvSpPr>
-          <p:cNvPr id="23" name="Text 21"/>
-          <p:cNvSpPr/>
-          <p:nvPr/>
-        </p:nvSpPr>
-        <p:spPr>
-          <a:xfrm>
-            <a:off x="6839712" y="4206240"/>
-            <a:ext cx="4480560" cy="457200"/>
+          <p:cNvPr id="13" name="Text 10"/>
+          <p:cNvSpPr/>
+          <p:nvPr/>
+        </p:nvSpPr>
+        <p:spPr>
+          <a:xfrm>
+            <a:off x="7635240" y="3858768"/>
+            <a:ext cx="347472" cy="347472"/>
+          </a:xfrm>
+          <a:prstGeom prst="rect">
+            <a:avLst/>
+          </a:prstGeom>
+          <a:noFill/>
+          <a:ln/>
+        </p:spPr>
+        <p:txBody>
+          <a:bodyPr wrap="square" lIns="0" tIns="0" rIns="0" bIns="0" rtlCol="0" anchor="ctr"/>
+          <a:lstStyle/>
+          <a:p>
+            <a:pPr algn="ctr" indent="0" marL="0">
+              <a:buNone/>
+            </a:pPr>
+            <a:r>
+              <a:rPr lang="en-US" sz="1300" b="1" dirty="0">
+                <a:solidFill>
+                  <a:srgbClr val="02C39A"/>
+                </a:solidFill>
+                <a:latin typeface="Calibri" pitchFamily="34" charset="0"/>
+                <a:ea typeface="Calibri" pitchFamily="34" charset="-122"/>
+                <a:cs typeface="Calibri" pitchFamily="34" charset="-120"/>
+              </a:rPr>
+              <a:t>3</a:t>
+            </a:r>
+            <a:endParaRPr lang="en-US" sz="1300" dirty="0"/>
+          </a:p>
+        </p:txBody>
+      </p:sp>
+      <p:sp>
+        <p:nvSpPr>
+          <p:cNvPr id="14" name="Text 11"/>
+          <p:cNvSpPr/>
+          <p:nvPr/>
+        </p:nvSpPr>
+        <p:spPr>
+          <a:xfrm>
+            <a:off x="8092440" y="3794760"/>
+            <a:ext cx="3429000" cy="914400"/>
           </a:xfrm>
           <a:prstGeom prst="rect">
             <a:avLst/>
@@ -8449,10 +8625,13 @@
           <a:lstStyle/>
           <a:p>
             <a:pPr indent="0" marL="0">
-              <a:buNone/>
-            </a:pPr>
-            <a:r>
-              <a:rPr lang="en-US" sz="1400" dirty="0">
+              <a:lnSpc>
+                <a:spcPct val="100000"/>
+              </a:lnSpc>
+              <a:buNone/>
+            </a:pPr>
+            <a:r>
+              <a:rPr lang="en-US" sz="1250" b="1" dirty="0">
                 <a:solidFill>
                   <a:srgbClr val="EAF0F8"/>
                 </a:solidFill>
@@ -8460,32 +8639,58 @@
                 <a:ea typeface="Calibri" pitchFamily="34" charset="-122"/>
                 <a:cs typeface="Calibri" pitchFamily="34" charset="-120"/>
               </a:rPr>
-              <a:t>ReAct agent + memory</a:t>
-            </a:r>
-            <a:endParaRPr lang="en-US" sz="1400" dirty="0"/>
-          </a:p>
-        </p:txBody>
-      </p:sp>
-      <p:sp>
-        <p:nvSpPr>
-          <p:cNvPr id="24" name="Shape 22"/>
-          <p:cNvSpPr/>
-          <p:nvPr/>
-        </p:nvSpPr>
-        <p:spPr>
-          <a:xfrm>
-            <a:off x="6611112" y="4855464"/>
-            <a:ext cx="109728" cy="109728"/>
+              <a:t>Configurable · Interrupts</a:t>
+            </a:r>
+            <a:pPr indent="0" marL="0">
+              <a:lnSpc>
+                <a:spcPct val="100000"/>
+              </a:lnSpc>
+              <a:buNone/>
+            </a:pPr>
+            <a:endParaRPr lang="en-US" sz="1250" dirty="0"/>
+          </a:p>
+          <a:p>
+            <a:pPr indent="0" marL="0">
+              <a:lnSpc>
+                <a:spcPct val="100000"/>
+              </a:lnSpc>
+              <a:buNone/>
+            </a:pPr>
+            <a:r>
+              <a:rPr lang="en-US" sz="1250" dirty="0">
+                <a:solidFill>
+                  <a:srgbClr val="9AAAC4"/>
+                </a:solidFill>
+                <a:latin typeface="Calibri" pitchFamily="34" charset="0"/>
+                <a:ea typeface="Calibri" pitchFamily="34" charset="-122"/>
+                <a:cs typeface="Calibri" pitchFamily="34" charset="-120"/>
+              </a:rPr>
+              <a:t>tweak config, add breakpoints (human-in-the-loop)</a:t>
+            </a:r>
+            <a:endParaRPr lang="en-US" sz="1250" dirty="0"/>
+          </a:p>
+        </p:txBody>
+      </p:sp>
+      <p:sp>
+        <p:nvSpPr>
+          <p:cNvPr id="15" name="Shape 12"/>
+          <p:cNvSpPr/>
+          <p:nvPr/>
+        </p:nvSpPr>
+        <p:spPr>
+          <a:xfrm>
+            <a:off x="7635240" y="4882896"/>
+            <a:ext cx="347472" cy="347472"/>
           </a:xfrm>
           <a:prstGeom prst="ellipse">
             <a:avLst/>
           </a:prstGeom>
           <a:solidFill>
-            <a:srgbClr val="00A896"/>
+            <a:srgbClr val="16233F"/>
           </a:solidFill>
-          <a:ln w="12700">
+          <a:ln w="19050">
             <a:solidFill>
-              <a:srgbClr val="00A896"/>
+              <a:srgbClr val="02C39A"/>
             </a:solidFill>
             <a:prstDash val="solid"/>
           </a:ln>
@@ -8493,14 +8698,53 @@
       </p:sp>
       <p:sp>
         <p:nvSpPr>
-          <p:cNvPr id="25" name="Text 23"/>
-          <p:cNvSpPr/>
-          <p:nvPr/>
-        </p:nvSpPr>
-        <p:spPr>
-          <a:xfrm>
-            <a:off x="6839712" y="4736592"/>
-            <a:ext cx="4480560" cy="457200"/>
+          <p:cNvPr id="16" name="Text 13"/>
+          <p:cNvSpPr/>
+          <p:nvPr/>
+        </p:nvSpPr>
+        <p:spPr>
+          <a:xfrm>
+            <a:off x="7635240" y="4882896"/>
+            <a:ext cx="347472" cy="347472"/>
+          </a:xfrm>
+          <a:prstGeom prst="rect">
+            <a:avLst/>
+          </a:prstGeom>
+          <a:noFill/>
+          <a:ln/>
+        </p:spPr>
+        <p:txBody>
+          <a:bodyPr wrap="square" lIns="0" tIns="0" rIns="0" bIns="0" rtlCol="0" anchor="ctr"/>
+          <a:lstStyle/>
+          <a:p>
+            <a:pPr algn="ctr" indent="0" marL="0">
+              <a:buNone/>
+            </a:pPr>
+            <a:r>
+              <a:rPr lang="en-US" sz="1300" b="1" dirty="0">
+                <a:solidFill>
+                  <a:srgbClr val="02C39A"/>
+                </a:solidFill>
+                <a:latin typeface="Calibri" pitchFamily="34" charset="0"/>
+                <a:ea typeface="Calibri" pitchFamily="34" charset="-122"/>
+                <a:cs typeface="Calibri" pitchFamily="34" charset="-120"/>
+              </a:rPr>
+              <a:t>4</a:t>
+            </a:r>
+            <a:endParaRPr lang="en-US" sz="1300" dirty="0"/>
+          </a:p>
+        </p:txBody>
+      </p:sp>
+      <p:sp>
+        <p:nvSpPr>
+          <p:cNvPr id="17" name="Text 14"/>
+          <p:cNvSpPr/>
+          <p:nvPr/>
+        </p:nvSpPr>
+        <p:spPr>
+          <a:xfrm>
+            <a:off x="8092440" y="4818888"/>
+            <a:ext cx="3429000" cy="914400"/>
           </a:xfrm>
           <a:prstGeom prst="rect">
             <a:avLst/>
@@ -8513,10 +8757,13 @@
           <a:lstStyle/>
           <a:p>
             <a:pPr indent="0" marL="0">
-              <a:buNone/>
-            </a:pPr>
-            <a:r>
-              <a:rPr lang="en-US" sz="1400" dirty="0">
+              <a:lnSpc>
+                <a:spcPct val="100000"/>
+              </a:lnSpc>
+              <a:buNone/>
+            </a:pPr>
+            <a:r>
+              <a:rPr lang="en-US" sz="1250" b="1" dirty="0">
                 <a:solidFill>
                   <a:srgbClr val="EAF0F8"/>
                 </a:solidFill>
@@ -8524,22 +8771,48 @@
                 <a:ea typeface="Calibri" pitchFamily="34" charset="-122"/>
                 <a:cs typeface="Calibri" pitchFamily="34" charset="-120"/>
               </a:rPr>
-              <a:t>🧪 human-in-the-loop</a:t>
-            </a:r>
-            <a:endParaRPr lang="en-US" sz="1400" dirty="0"/>
-          </a:p>
-        </p:txBody>
-      </p:sp>
-      <p:sp>
-        <p:nvSpPr>
-          <p:cNvPr id="26" name="Text 24"/>
-          <p:cNvSpPr/>
-          <p:nvPr/>
-        </p:nvSpPr>
-        <p:spPr>
-          <a:xfrm>
-            <a:off x="640080" y="5715000"/>
-            <a:ext cx="10881360" cy="365760"/>
+              <a:t>Submit → run</a:t>
+            </a:r>
+            <a:pPr indent="0" marL="0">
+              <a:lnSpc>
+                <a:spcPct val="100000"/>
+              </a:lnSpc>
+              <a:buNone/>
+            </a:pPr>
+            <a:endParaRPr lang="en-US" sz="1250" dirty="0"/>
+          </a:p>
+          <a:p>
+            <a:pPr indent="0" marL="0">
+              <a:lnSpc>
+                <a:spcPct val="100000"/>
+              </a:lnSpc>
+              <a:buNone/>
+            </a:pPr>
+            <a:r>
+              <a:rPr lang="en-US" sz="1250" dirty="0">
+                <a:solidFill>
+                  <a:srgbClr val="9AAAC4"/>
+                </a:solidFill>
+                <a:latin typeface="Calibri" pitchFamily="34" charset="0"/>
+                <a:ea typeface="Calibri" pitchFamily="34" charset="-122"/>
+                <a:cs typeface="Calibri" pitchFamily="34" charset="-120"/>
+              </a:rPr>
+              <a:t>watch it execute, then fork &amp; replay from any step</a:t>
+            </a:r>
+            <a:endParaRPr lang="en-US" sz="1250" dirty="0"/>
+          </a:p>
+        </p:txBody>
+      </p:sp>
+      <p:sp>
+        <p:nvSpPr>
+          <p:cNvPr id="18" name="Text 15"/>
+          <p:cNvSpPr/>
+          <p:nvPr/>
+        </p:nvSpPr>
+        <p:spPr>
+          <a:xfrm>
+            <a:off x="548640" y="6172200"/>
+            <a:ext cx="10881360" cy="274320"/>
           </a:xfrm>
           <a:prstGeom prst="rect">
             <a:avLst/>
@@ -8555,23 +8828,23 @@
               <a:buNone/>
             </a:pPr>
             <a:r>
-              <a:rPr lang="en-US" sz="1300" i="1" dirty="0">
-                <a:solidFill>
-                  <a:srgbClr val="00A896"/>
-                </a:solidFill>
-                <a:latin typeface="Calibri" pitchFamily="34" charset="0"/>
-                <a:ea typeface="Calibri" pitchFamily="34" charset="-122"/>
-                <a:cs typeface="Calibri" pitchFamily="34" charset="-120"/>
-              </a:rPr>
-              <a:t>Plus:  langgraph dev  →  open LangGraph Studio to watch the graph run, inspect state, fork &amp; replay.</a:t>
-            </a:r>
-            <a:endParaRPr lang="en-US" sz="1300" dirty="0"/>
-          </a:p>
-        </p:txBody>
-      </p:sp>
-      <p:sp>
-        <p:nvSpPr>
-          <p:cNvPr id="27" name="Text 25"/>
+              <a:rPr lang="en-US" sz="950" i="1" dirty="0">
+                <a:solidFill>
+                  <a:srgbClr val="9AAAC4"/>
+                </a:solidFill>
+                <a:latin typeface="Calibri" pitchFamily="34" charset="0"/>
+                <a:ea typeface="Calibri" pitchFamily="34" charset="-122"/>
+                <a:cs typeface="Calibri" pitchFamily="34" charset="-120"/>
+              </a:rPr>
+              <a:t>Screenshot: langgraph-engineer by Harrison Chase (LangChain) · open source</a:t>
+            </a:r>
+            <a:endParaRPr lang="en-US" sz="950" dirty="0"/>
+          </a:p>
+        </p:txBody>
+      </p:sp>
+      <p:sp>
+        <p:nvSpPr>
+          <p:cNvPr id="19" name="Text 16"/>
           <p:cNvSpPr/>
           <p:nvPr/>
         </p:nvSpPr>
@@ -8610,7 +8883,7 @@
       </p:sp>
       <p:sp>
         <p:nvSpPr>
-          <p:cNvPr id="28" name="Text 26"/>
+          <p:cNvPr id="20" name="Text 17"/>
           <p:cNvSpPr/>
           <p:nvPr/>
         </p:nvSpPr>
@@ -8681,24 +8954,214 @@
       </p:grpSpPr>
       <p:sp>
         <p:nvSpPr>
-          <p:cNvPr id="2" name="Shape 0"/>
-          <p:cNvSpPr/>
-          <p:nvPr/>
-        </p:nvSpPr>
-        <p:spPr>
-          <a:xfrm>
-            <a:off x="-2011680" y="3291840"/>
-            <a:ext cx="6400800" cy="6400800"/>
+          <p:cNvPr id="2" name="Text 0"/>
+          <p:cNvSpPr/>
+          <p:nvPr/>
+        </p:nvSpPr>
+        <p:spPr>
+          <a:xfrm>
+            <a:off x="640080" y="502920"/>
+            <a:ext cx="10058400" cy="274320"/>
+          </a:xfrm>
+          <a:prstGeom prst="rect">
+            <a:avLst/>
+          </a:prstGeom>
+          <a:noFill/>
+          <a:ln/>
+        </p:spPr>
+        <p:txBody>
+          <a:bodyPr wrap="square" lIns="0" tIns="0" rIns="0" bIns="0" rtlCol="0" anchor="ctr"/>
+          <a:lstStyle/>
+          <a:p>
+            <a:pPr indent="0" marL="0">
+              <a:buNone/>
+            </a:pPr>
+            <a:r>
+              <a:rPr lang="en-US" sz="1200" b="1" spc="200" kern="0" dirty="0">
+                <a:solidFill>
+                  <a:srgbClr val="02C39A"/>
+                </a:solidFill>
+                <a:latin typeface="Calibri" pitchFamily="34" charset="0"/>
+                <a:ea typeface="Calibri" pitchFamily="34" charset="-122"/>
+                <a:cs typeface="Calibri" pitchFamily="34" charset="-120"/>
+              </a:rPr>
+              <a:t>YOUR TURN</a:t>
+            </a:r>
+            <a:endParaRPr lang="en-US" sz="1200" dirty="0"/>
+          </a:p>
+        </p:txBody>
+      </p:sp>
+      <p:sp>
+        <p:nvSpPr>
+          <p:cNvPr id="3" name="Text 1"/>
+          <p:cNvSpPr/>
+          <p:nvPr/>
+        </p:nvSpPr>
+        <p:spPr>
+          <a:xfrm>
+            <a:off x="640080" y="822960"/>
+            <a:ext cx="10972800" cy="822960"/>
+          </a:xfrm>
+          <a:prstGeom prst="rect">
+            <a:avLst/>
+          </a:prstGeom>
+          <a:noFill/>
+          <a:ln/>
+        </p:spPr>
+        <p:txBody>
+          <a:bodyPr wrap="square" lIns="0" tIns="0" rIns="0" bIns="0" rtlCol="0" anchor="ctr"/>
+          <a:lstStyle/>
+          <a:p>
+            <a:pPr indent="0" marL="0">
+              <a:buNone/>
+            </a:pPr>
+            <a:r>
+              <a:rPr lang="en-US" sz="3400" b="1" dirty="0">
+                <a:solidFill>
+                  <a:srgbClr val="EAF0F8"/>
+                </a:solidFill>
+                <a:latin typeface="Calibri" pitchFamily="34" charset="0"/>
+                <a:ea typeface="Calibri" pitchFamily="34" charset="-122"/>
+                <a:cs typeface="Calibri" pitchFamily="34" charset="-120"/>
+              </a:rPr>
+              <a:t>What you'll run</a:t>
+            </a:r>
+            <a:endParaRPr lang="en-US" sz="3400" dirty="0"/>
+          </a:p>
+        </p:txBody>
+      </p:sp>
+      <p:sp>
+        <p:nvSpPr>
+          <p:cNvPr id="4" name="Shape 2"/>
+          <p:cNvSpPr/>
+          <p:nvPr/>
+        </p:nvSpPr>
+        <p:spPr>
+          <a:xfrm>
+            <a:off x="640080" y="1920240"/>
+            <a:ext cx="5303520" cy="3566160"/>
+          </a:xfrm>
+          <a:prstGeom prst="roundRect">
+            <a:avLst>
+              <a:gd name="adj" fmla="val 2051"/>
+            </a:avLst>
+          </a:prstGeom>
+          <a:solidFill>
+            <a:srgbClr val="16233F"/>
+          </a:solidFill>
+          <a:ln w="19050">
+            <a:solidFill>
+              <a:srgbClr val="02C39A"/>
+            </a:solidFill>
+            <a:prstDash val="solid"/>
+          </a:ln>
+          <a:effectLst>
+            <a:outerShdw sx="100000" sy="100000" kx="0" ky="0" algn="bl" rotWithShape="0" blurRad="101600" dist="38100" dir="5400000">
+              <a:srgbClr val="000000">
+                <a:alpha val="35000"/>
+              </a:srgbClr>
+            </a:outerShdw>
+          </a:effectLst>
+        </p:spPr>
+      </p:sp>
+      <p:sp>
+        <p:nvSpPr>
+          <p:cNvPr id="5" name="Text 3"/>
+          <p:cNvSpPr/>
+          <p:nvPr/>
+        </p:nvSpPr>
+        <p:spPr>
+          <a:xfrm>
+            <a:off x="960120" y="2148840"/>
+            <a:ext cx="4572000" cy="274320"/>
+          </a:xfrm>
+          <a:prstGeom prst="rect">
+            <a:avLst/>
+          </a:prstGeom>
+          <a:noFill/>
+          <a:ln/>
+        </p:spPr>
+        <p:txBody>
+          <a:bodyPr wrap="square" lIns="0" tIns="0" rIns="0" bIns="0" rtlCol="0" anchor="ctr"/>
+          <a:lstStyle/>
+          <a:p>
+            <a:pPr indent="0" marL="0">
+              <a:buNone/>
+            </a:pPr>
+            <a:r>
+              <a:rPr lang="en-US" sz="1100" b="1" spc="200" kern="0" dirty="0">
+                <a:solidFill>
+                  <a:srgbClr val="02C39A"/>
+                </a:solidFill>
+                <a:latin typeface="Calibri" pitchFamily="34" charset="0"/>
+                <a:ea typeface="Calibri" pitchFamily="34" charset="-122"/>
+                <a:cs typeface="Calibri" pitchFamily="34" charset="-120"/>
+              </a:rPr>
+              <a:t>NOTEBOOK 01</a:t>
+            </a:r>
+            <a:endParaRPr lang="en-US" sz="1100" dirty="0"/>
+          </a:p>
+        </p:txBody>
+      </p:sp>
+      <p:sp>
+        <p:nvSpPr>
+          <p:cNvPr id="6" name="Text 4"/>
+          <p:cNvSpPr/>
+          <p:nvPr/>
+        </p:nvSpPr>
+        <p:spPr>
+          <a:xfrm>
+            <a:off x="960120" y="2423160"/>
+            <a:ext cx="4572000" cy="548640"/>
+          </a:xfrm>
+          <a:prstGeom prst="rect">
+            <a:avLst/>
+          </a:prstGeom>
+          <a:noFill/>
+          <a:ln/>
+        </p:spPr>
+        <p:txBody>
+          <a:bodyPr wrap="square" lIns="0" tIns="0" rIns="0" bIns="0" rtlCol="0" anchor="ctr"/>
+          <a:lstStyle/>
+          <a:p>
+            <a:pPr indent="0" marL="0">
+              <a:buNone/>
+            </a:pPr>
+            <a:r>
+              <a:rPr lang="en-US" sz="2400" b="1" dirty="0">
+                <a:solidFill>
+                  <a:srgbClr val="EAF0F8"/>
+                </a:solidFill>
+                <a:latin typeface="Calibri" pitchFamily="34" charset="0"/>
+                <a:ea typeface="Calibri" pitchFamily="34" charset="-122"/>
+                <a:cs typeface="Calibri" pitchFamily="34" charset="-120"/>
+              </a:rPr>
+              <a:t>LangChain</a:t>
+            </a:r>
+            <a:endParaRPr lang="en-US" sz="2400" dirty="0"/>
+          </a:p>
+        </p:txBody>
+      </p:sp>
+      <p:sp>
+        <p:nvSpPr>
+          <p:cNvPr id="7" name="Shape 5"/>
+          <p:cNvSpPr/>
+          <p:nvPr/>
+        </p:nvSpPr>
+        <p:spPr>
+          <a:xfrm>
+            <a:off x="1005840" y="3264408"/>
+            <a:ext cx="109728" cy="109728"/>
           </a:xfrm>
           <a:prstGeom prst="ellipse">
             <a:avLst/>
           </a:prstGeom>
           <a:solidFill>
-            <a:srgbClr val="0F1A30"/>
+            <a:srgbClr val="02C39A"/>
           </a:solidFill>
           <a:ln w="12700">
             <a:solidFill>
-              <a:srgbClr val="24334F"/>
+              <a:srgbClr val="02C39A"/>
             </a:solidFill>
             <a:prstDash val="solid"/>
           </a:ln>
@@ -8706,20 +9169,363 @@
       </p:sp>
       <p:sp>
         <p:nvSpPr>
-          <p:cNvPr id="3" name="Shape 1"/>
-          <p:cNvSpPr/>
-          <p:nvPr/>
-        </p:nvSpPr>
-        <p:spPr>
-          <a:xfrm>
-            <a:off x="9326880" y="-2377440"/>
-            <a:ext cx="5486400" cy="5486400"/>
+          <p:cNvPr id="8" name="Text 6"/>
+          <p:cNvSpPr/>
+          <p:nvPr/>
+        </p:nvSpPr>
+        <p:spPr>
+          <a:xfrm>
+            <a:off x="1234440" y="3145536"/>
+            <a:ext cx="4480560" cy="457200"/>
+          </a:xfrm>
+          <a:prstGeom prst="rect">
+            <a:avLst/>
+          </a:prstGeom>
+          <a:noFill/>
+          <a:ln/>
+        </p:spPr>
+        <p:txBody>
+          <a:bodyPr wrap="square" lIns="0" tIns="0" rIns="0" bIns="0" rtlCol="0" anchor="t"/>
+          <a:lstStyle/>
+          <a:p>
+            <a:pPr indent="0" marL="0">
+              <a:buNone/>
+            </a:pPr>
+            <a:r>
+              <a:rPr lang="en-US" sz="1400" dirty="0">
+                <a:solidFill>
+                  <a:srgbClr val="EAF0F8"/>
+                </a:solidFill>
+                <a:latin typeface="Calibri" pitchFamily="34" charset="0"/>
+                <a:ea typeface="Calibri" pitchFamily="34" charset="-122"/>
+                <a:cs typeface="Calibri" pitchFamily="34" charset="-120"/>
+              </a:rPr>
+              <a:t>LCEL chain</a:t>
+            </a:r>
+            <a:endParaRPr lang="en-US" sz="1400" dirty="0"/>
+          </a:p>
+        </p:txBody>
+      </p:sp>
+      <p:sp>
+        <p:nvSpPr>
+          <p:cNvPr id="9" name="Shape 7"/>
+          <p:cNvSpPr/>
+          <p:nvPr/>
+        </p:nvSpPr>
+        <p:spPr>
+          <a:xfrm>
+            <a:off x="1005840" y="3794760"/>
+            <a:ext cx="109728" cy="109728"/>
           </a:xfrm>
           <a:prstGeom prst="ellipse">
             <a:avLst/>
           </a:prstGeom>
           <a:solidFill>
-            <a:srgbClr val="0F1A30"/>
+            <a:srgbClr val="02C39A"/>
+          </a:solidFill>
+          <a:ln w="12700">
+            <a:solidFill>
+              <a:srgbClr val="02C39A"/>
+            </a:solidFill>
+            <a:prstDash val="solid"/>
+          </a:ln>
+        </p:spPr>
+      </p:sp>
+      <p:sp>
+        <p:nvSpPr>
+          <p:cNvPr id="10" name="Text 8"/>
+          <p:cNvSpPr/>
+          <p:nvPr/>
+        </p:nvSpPr>
+        <p:spPr>
+          <a:xfrm>
+            <a:off x="1234440" y="3675888"/>
+            <a:ext cx="4480560" cy="457200"/>
+          </a:xfrm>
+          <a:prstGeom prst="rect">
+            <a:avLst/>
+          </a:prstGeom>
+          <a:noFill/>
+          <a:ln/>
+        </p:spPr>
+        <p:txBody>
+          <a:bodyPr wrap="square" lIns="0" tIns="0" rIns="0" bIns="0" rtlCol="0" anchor="t"/>
+          <a:lstStyle/>
+          <a:p>
+            <a:pPr indent="0" marL="0">
+              <a:buNone/>
+            </a:pPr>
+            <a:r>
+              <a:rPr lang="en-US" sz="1400" dirty="0">
+                <a:solidFill>
+                  <a:srgbClr val="EAF0F8"/>
+                </a:solidFill>
+                <a:latin typeface="Calibri" pitchFamily="34" charset="0"/>
+                <a:ea typeface="Calibri" pitchFamily="34" charset="-122"/>
+                <a:cs typeface="Calibri" pitchFamily="34" charset="-120"/>
+              </a:rPr>
+              <a:t>tool calling + closing the loop</a:t>
+            </a:r>
+            <a:endParaRPr lang="en-US" sz="1400" dirty="0"/>
+          </a:p>
+        </p:txBody>
+      </p:sp>
+      <p:sp>
+        <p:nvSpPr>
+          <p:cNvPr id="11" name="Shape 9"/>
+          <p:cNvSpPr/>
+          <p:nvPr/>
+        </p:nvSpPr>
+        <p:spPr>
+          <a:xfrm>
+            <a:off x="1005840" y="4325112"/>
+            <a:ext cx="109728" cy="109728"/>
+          </a:xfrm>
+          <a:prstGeom prst="ellipse">
+            <a:avLst/>
+          </a:prstGeom>
+          <a:solidFill>
+            <a:srgbClr val="02C39A"/>
+          </a:solidFill>
+          <a:ln w="12700">
+            <a:solidFill>
+              <a:srgbClr val="02C39A"/>
+            </a:solidFill>
+            <a:prstDash val="solid"/>
+          </a:ln>
+        </p:spPr>
+      </p:sp>
+      <p:sp>
+        <p:nvSpPr>
+          <p:cNvPr id="12" name="Text 10"/>
+          <p:cNvSpPr/>
+          <p:nvPr/>
+        </p:nvSpPr>
+        <p:spPr>
+          <a:xfrm>
+            <a:off x="1234440" y="4206240"/>
+            <a:ext cx="4480560" cy="457200"/>
+          </a:xfrm>
+          <a:prstGeom prst="rect">
+            <a:avLst/>
+          </a:prstGeom>
+          <a:noFill/>
+          <a:ln/>
+        </p:spPr>
+        <p:txBody>
+          <a:bodyPr wrap="square" lIns="0" tIns="0" rIns="0" bIns="0" rtlCol="0" anchor="t"/>
+          <a:lstStyle/>
+          <a:p>
+            <a:pPr indent="0" marL="0">
+              <a:buNone/>
+            </a:pPr>
+            <a:r>
+              <a:rPr lang="en-US" sz="1400" dirty="0">
+                <a:solidFill>
+                  <a:srgbClr val="EAF0F8"/>
+                </a:solidFill>
+                <a:latin typeface="Calibri" pitchFamily="34" charset="0"/>
+                <a:ea typeface="Calibri" pitchFamily="34" charset="-122"/>
+                <a:cs typeface="Calibri" pitchFamily="34" charset="-120"/>
+              </a:rPr>
+              <a:t>streaming</a:t>
+            </a:r>
+            <a:endParaRPr lang="en-US" sz="1400" dirty="0"/>
+          </a:p>
+        </p:txBody>
+      </p:sp>
+      <p:sp>
+        <p:nvSpPr>
+          <p:cNvPr id="13" name="Shape 11"/>
+          <p:cNvSpPr/>
+          <p:nvPr/>
+        </p:nvSpPr>
+        <p:spPr>
+          <a:xfrm>
+            <a:off x="1005840" y="4855464"/>
+            <a:ext cx="109728" cy="109728"/>
+          </a:xfrm>
+          <a:prstGeom prst="ellipse">
+            <a:avLst/>
+          </a:prstGeom>
+          <a:solidFill>
+            <a:srgbClr val="02C39A"/>
+          </a:solidFill>
+          <a:ln w="12700">
+            <a:solidFill>
+              <a:srgbClr val="02C39A"/>
+            </a:solidFill>
+            <a:prstDash val="solid"/>
+          </a:ln>
+        </p:spPr>
+      </p:sp>
+      <p:sp>
+        <p:nvSpPr>
+          <p:cNvPr id="14" name="Text 12"/>
+          <p:cNvSpPr/>
+          <p:nvPr/>
+        </p:nvSpPr>
+        <p:spPr>
+          <a:xfrm>
+            <a:off x="1234440" y="4736592"/>
+            <a:ext cx="4480560" cy="457200"/>
+          </a:xfrm>
+          <a:prstGeom prst="rect">
+            <a:avLst/>
+          </a:prstGeom>
+          <a:noFill/>
+          <a:ln/>
+        </p:spPr>
+        <p:txBody>
+          <a:bodyPr wrap="square" lIns="0" tIns="0" rIns="0" bIns="0" rtlCol="0" anchor="t"/>
+          <a:lstStyle/>
+          <a:p>
+            <a:pPr indent="0" marL="0">
+              <a:buNone/>
+            </a:pPr>
+            <a:r>
+              <a:rPr lang="en-US" sz="1400" dirty="0">
+                <a:solidFill>
+                  <a:srgbClr val="EAF0F8"/>
+                </a:solidFill>
+                <a:latin typeface="Calibri" pitchFamily="34" charset="0"/>
+                <a:ea typeface="Calibri" pitchFamily="34" charset="-122"/>
+                <a:cs typeface="Calibri" pitchFamily="34" charset="-120"/>
+              </a:rPr>
+              <a:t>🧪 add a 2nd tool</a:t>
+            </a:r>
+            <a:endParaRPr lang="en-US" sz="1400" dirty="0"/>
+          </a:p>
+        </p:txBody>
+      </p:sp>
+      <p:sp>
+        <p:nvSpPr>
+          <p:cNvPr id="15" name="Shape 13"/>
+          <p:cNvSpPr/>
+          <p:nvPr/>
+        </p:nvSpPr>
+        <p:spPr>
+          <a:xfrm>
+            <a:off x="6245352" y="1920240"/>
+            <a:ext cx="5303520" cy="3566160"/>
+          </a:xfrm>
+          <a:prstGeom prst="roundRect">
+            <a:avLst>
+              <a:gd name="adj" fmla="val 2051"/>
+            </a:avLst>
+          </a:prstGeom>
+          <a:solidFill>
+            <a:srgbClr val="16233F"/>
+          </a:solidFill>
+          <a:ln w="19050">
+            <a:solidFill>
+              <a:srgbClr val="00A896"/>
+            </a:solidFill>
+            <a:prstDash val="solid"/>
+          </a:ln>
+          <a:effectLst>
+            <a:outerShdw sx="100000" sy="100000" kx="0" ky="0" algn="bl" rotWithShape="0" blurRad="101600" dist="38100" dir="5400000">
+              <a:srgbClr val="000000">
+                <a:alpha val="35000"/>
+              </a:srgbClr>
+            </a:outerShdw>
+          </a:effectLst>
+        </p:spPr>
+      </p:sp>
+      <p:sp>
+        <p:nvSpPr>
+          <p:cNvPr id="16" name="Text 14"/>
+          <p:cNvSpPr/>
+          <p:nvPr/>
+        </p:nvSpPr>
+        <p:spPr>
+          <a:xfrm>
+            <a:off x="6565392" y="2148840"/>
+            <a:ext cx="4572000" cy="274320"/>
+          </a:xfrm>
+          <a:prstGeom prst="rect">
+            <a:avLst/>
+          </a:prstGeom>
+          <a:noFill/>
+          <a:ln/>
+        </p:spPr>
+        <p:txBody>
+          <a:bodyPr wrap="square" lIns="0" tIns="0" rIns="0" bIns="0" rtlCol="0" anchor="ctr"/>
+          <a:lstStyle/>
+          <a:p>
+            <a:pPr indent="0" marL="0">
+              <a:buNone/>
+            </a:pPr>
+            <a:r>
+              <a:rPr lang="en-US" sz="1100" b="1" spc="200" kern="0" dirty="0">
+                <a:solidFill>
+                  <a:srgbClr val="00A896"/>
+                </a:solidFill>
+                <a:latin typeface="Calibri" pitchFamily="34" charset="0"/>
+                <a:ea typeface="Calibri" pitchFamily="34" charset="-122"/>
+                <a:cs typeface="Calibri" pitchFamily="34" charset="-120"/>
+              </a:rPr>
+              <a:t>NOTEBOOK 02</a:t>
+            </a:r>
+            <a:endParaRPr lang="en-US" sz="1100" dirty="0"/>
+          </a:p>
+        </p:txBody>
+      </p:sp>
+      <p:sp>
+        <p:nvSpPr>
+          <p:cNvPr id="17" name="Text 15"/>
+          <p:cNvSpPr/>
+          <p:nvPr/>
+        </p:nvSpPr>
+        <p:spPr>
+          <a:xfrm>
+            <a:off x="6565392" y="2423160"/>
+            <a:ext cx="4572000" cy="548640"/>
+          </a:xfrm>
+          <a:prstGeom prst="rect">
+            <a:avLst/>
+          </a:prstGeom>
+          <a:noFill/>
+          <a:ln/>
+        </p:spPr>
+        <p:txBody>
+          <a:bodyPr wrap="square" lIns="0" tIns="0" rIns="0" bIns="0" rtlCol="0" anchor="ctr"/>
+          <a:lstStyle/>
+          <a:p>
+            <a:pPr indent="0" marL="0">
+              <a:buNone/>
+            </a:pPr>
+            <a:r>
+              <a:rPr lang="en-US" sz="2400" b="1" dirty="0">
+                <a:solidFill>
+                  <a:srgbClr val="EAF0F8"/>
+                </a:solidFill>
+                <a:latin typeface="Calibri" pitchFamily="34" charset="0"/>
+                <a:ea typeface="Calibri" pitchFamily="34" charset="-122"/>
+                <a:cs typeface="Calibri" pitchFamily="34" charset="-120"/>
+              </a:rPr>
+              <a:t>LangGraph</a:t>
+            </a:r>
+            <a:endParaRPr lang="en-US" sz="2400" dirty="0"/>
+          </a:p>
+        </p:txBody>
+      </p:sp>
+      <p:sp>
+        <p:nvSpPr>
+          <p:cNvPr id="18" name="Shape 16"/>
+          <p:cNvSpPr/>
+          <p:nvPr/>
+        </p:nvSpPr>
+        <p:spPr>
+          <a:xfrm>
+            <a:off x="6611112" y="3264408"/>
+            <a:ext cx="109728" cy="109728"/>
+          </a:xfrm>
+          <a:prstGeom prst="ellipse">
+            <a:avLst/>
+          </a:prstGeom>
+          <a:solidFill>
+            <a:srgbClr val="00A896"/>
           </a:solidFill>
           <a:ln w="12700">
             <a:solidFill>
@@ -8731,24 +9537,63 @@
       </p:sp>
       <p:sp>
         <p:nvSpPr>
-          <p:cNvPr id="4" name="Shape 2"/>
-          <p:cNvSpPr/>
-          <p:nvPr/>
-        </p:nvSpPr>
-        <p:spPr>
-          <a:xfrm>
-            <a:off x="10424160" y="4206240"/>
-            <a:ext cx="3108960" cy="3108960"/>
+          <p:cNvPr id="19" name="Text 17"/>
+          <p:cNvSpPr/>
+          <p:nvPr/>
+        </p:nvSpPr>
+        <p:spPr>
+          <a:xfrm>
+            <a:off x="6839712" y="3145536"/>
+            <a:ext cx="4480560" cy="457200"/>
+          </a:xfrm>
+          <a:prstGeom prst="rect">
+            <a:avLst/>
+          </a:prstGeom>
+          <a:noFill/>
+          <a:ln/>
+        </p:spPr>
+        <p:txBody>
+          <a:bodyPr wrap="square" lIns="0" tIns="0" rIns="0" bIns="0" rtlCol="0" anchor="t"/>
+          <a:lstStyle/>
+          <a:p>
+            <a:pPr indent="0" marL="0">
+              <a:buNone/>
+            </a:pPr>
+            <a:r>
+              <a:rPr lang="en-US" sz="1400" dirty="0">
+                <a:solidFill>
+                  <a:srgbClr val="EAF0F8"/>
+                </a:solidFill>
+                <a:latin typeface="Calibri" pitchFamily="34" charset="0"/>
+                <a:ea typeface="Calibri" pitchFamily="34" charset="-122"/>
+                <a:cs typeface="Calibri" pitchFamily="34" charset="-120"/>
+              </a:rPr>
+              <a:t>state graph from scratch</a:t>
+            </a:r>
+            <a:endParaRPr lang="en-US" sz="1400" dirty="0"/>
+          </a:p>
+        </p:txBody>
+      </p:sp>
+      <p:sp>
+        <p:nvSpPr>
+          <p:cNvPr id="20" name="Shape 18"/>
+          <p:cNvSpPr/>
+          <p:nvPr/>
+        </p:nvSpPr>
+        <p:spPr>
+          <a:xfrm>
+            <a:off x="6611112" y="3794760"/>
+            <a:ext cx="109728" cy="109728"/>
           </a:xfrm>
           <a:prstGeom prst="ellipse">
             <a:avLst/>
           </a:prstGeom>
           <a:solidFill>
-            <a:srgbClr val="0B1220"/>
+            <a:srgbClr val="00A896"/>
           </a:solidFill>
-          <a:ln w="19050">
+          <a:ln w="12700">
             <a:solidFill>
-              <a:srgbClr val="02C39A"/>
+              <a:srgbClr val="00A896"/>
             </a:solidFill>
             <a:prstDash val="solid"/>
           </a:ln>
@@ -8756,14 +9601,181 @@
       </p:sp>
       <p:sp>
         <p:nvSpPr>
-          <p:cNvPr id="5" name="Text 3"/>
-          <p:cNvSpPr/>
-          <p:nvPr/>
-        </p:nvSpPr>
-        <p:spPr>
-          <a:xfrm>
-            <a:off x="914400" y="2331720"/>
-            <a:ext cx="9144000" cy="457200"/>
+          <p:cNvPr id="21" name="Text 19"/>
+          <p:cNvSpPr/>
+          <p:nvPr/>
+        </p:nvSpPr>
+        <p:spPr>
+          <a:xfrm>
+            <a:off x="6839712" y="3675888"/>
+            <a:ext cx="4480560" cy="457200"/>
+          </a:xfrm>
+          <a:prstGeom prst="rect">
+            <a:avLst/>
+          </a:prstGeom>
+          <a:noFill/>
+          <a:ln/>
+        </p:spPr>
+        <p:txBody>
+          <a:bodyPr wrap="square" lIns="0" tIns="0" rIns="0" bIns="0" rtlCol="0" anchor="t"/>
+          <a:lstStyle/>
+          <a:p>
+            <a:pPr indent="0" marL="0">
+              <a:buNone/>
+            </a:pPr>
+            <a:r>
+              <a:rPr lang="en-US" sz="1400" dirty="0">
+                <a:solidFill>
+                  <a:srgbClr val="EAF0F8"/>
+                </a:solidFill>
+                <a:latin typeface="Calibri" pitchFamily="34" charset="0"/>
+                <a:ea typeface="Calibri" pitchFamily="34" charset="-122"/>
+                <a:cs typeface="Calibri" pitchFamily="34" charset="-120"/>
+              </a:rPr>
+              <a:t>conditional edges</a:t>
+            </a:r>
+            <a:endParaRPr lang="en-US" sz="1400" dirty="0"/>
+          </a:p>
+        </p:txBody>
+      </p:sp>
+      <p:sp>
+        <p:nvSpPr>
+          <p:cNvPr id="22" name="Shape 20"/>
+          <p:cNvSpPr/>
+          <p:nvPr/>
+        </p:nvSpPr>
+        <p:spPr>
+          <a:xfrm>
+            <a:off x="6611112" y="4325112"/>
+            <a:ext cx="109728" cy="109728"/>
+          </a:xfrm>
+          <a:prstGeom prst="ellipse">
+            <a:avLst/>
+          </a:prstGeom>
+          <a:solidFill>
+            <a:srgbClr val="00A896"/>
+          </a:solidFill>
+          <a:ln w="12700">
+            <a:solidFill>
+              <a:srgbClr val="00A896"/>
+            </a:solidFill>
+            <a:prstDash val="solid"/>
+          </a:ln>
+        </p:spPr>
+      </p:sp>
+      <p:sp>
+        <p:nvSpPr>
+          <p:cNvPr id="23" name="Text 21"/>
+          <p:cNvSpPr/>
+          <p:nvPr/>
+        </p:nvSpPr>
+        <p:spPr>
+          <a:xfrm>
+            <a:off x="6839712" y="4206240"/>
+            <a:ext cx="4480560" cy="457200"/>
+          </a:xfrm>
+          <a:prstGeom prst="rect">
+            <a:avLst/>
+          </a:prstGeom>
+          <a:noFill/>
+          <a:ln/>
+        </p:spPr>
+        <p:txBody>
+          <a:bodyPr wrap="square" lIns="0" tIns="0" rIns="0" bIns="0" rtlCol="0" anchor="t"/>
+          <a:lstStyle/>
+          <a:p>
+            <a:pPr indent="0" marL="0">
+              <a:buNone/>
+            </a:pPr>
+            <a:r>
+              <a:rPr lang="en-US" sz="1400" dirty="0">
+                <a:solidFill>
+                  <a:srgbClr val="EAF0F8"/>
+                </a:solidFill>
+                <a:latin typeface="Calibri" pitchFamily="34" charset="0"/>
+                <a:ea typeface="Calibri" pitchFamily="34" charset="-122"/>
+                <a:cs typeface="Calibri" pitchFamily="34" charset="-120"/>
+              </a:rPr>
+              <a:t>ReAct agent + memory</a:t>
+            </a:r>
+            <a:endParaRPr lang="en-US" sz="1400" dirty="0"/>
+          </a:p>
+        </p:txBody>
+      </p:sp>
+      <p:sp>
+        <p:nvSpPr>
+          <p:cNvPr id="24" name="Shape 22"/>
+          <p:cNvSpPr/>
+          <p:nvPr/>
+        </p:nvSpPr>
+        <p:spPr>
+          <a:xfrm>
+            <a:off x="6611112" y="4855464"/>
+            <a:ext cx="109728" cy="109728"/>
+          </a:xfrm>
+          <a:prstGeom prst="ellipse">
+            <a:avLst/>
+          </a:prstGeom>
+          <a:solidFill>
+            <a:srgbClr val="00A896"/>
+          </a:solidFill>
+          <a:ln w="12700">
+            <a:solidFill>
+              <a:srgbClr val="00A896"/>
+            </a:solidFill>
+            <a:prstDash val="solid"/>
+          </a:ln>
+        </p:spPr>
+      </p:sp>
+      <p:sp>
+        <p:nvSpPr>
+          <p:cNvPr id="25" name="Text 23"/>
+          <p:cNvSpPr/>
+          <p:nvPr/>
+        </p:nvSpPr>
+        <p:spPr>
+          <a:xfrm>
+            <a:off x="6839712" y="4736592"/>
+            <a:ext cx="4480560" cy="457200"/>
+          </a:xfrm>
+          <a:prstGeom prst="rect">
+            <a:avLst/>
+          </a:prstGeom>
+          <a:noFill/>
+          <a:ln/>
+        </p:spPr>
+        <p:txBody>
+          <a:bodyPr wrap="square" lIns="0" tIns="0" rIns="0" bIns="0" rtlCol="0" anchor="t"/>
+          <a:lstStyle/>
+          <a:p>
+            <a:pPr indent="0" marL="0">
+              <a:buNone/>
+            </a:pPr>
+            <a:r>
+              <a:rPr lang="en-US" sz="1400" dirty="0">
+                <a:solidFill>
+                  <a:srgbClr val="EAF0F8"/>
+                </a:solidFill>
+                <a:latin typeface="Calibri" pitchFamily="34" charset="0"/>
+                <a:ea typeface="Calibri" pitchFamily="34" charset="-122"/>
+                <a:cs typeface="Calibri" pitchFamily="34" charset="-120"/>
+              </a:rPr>
+              <a:t>🧪 human-in-the-loop</a:t>
+            </a:r>
+            <a:endParaRPr lang="en-US" sz="1400" dirty="0"/>
+          </a:p>
+        </p:txBody>
+      </p:sp>
+      <p:sp>
+        <p:nvSpPr>
+          <p:cNvPr id="26" name="Text 24"/>
+          <p:cNvSpPr/>
+          <p:nvPr/>
+        </p:nvSpPr>
+        <p:spPr>
+          <a:xfrm>
+            <a:off x="640080" y="5715000"/>
+            <a:ext cx="10881360" cy="365760"/>
           </a:xfrm>
           <a:prstGeom prst="rect">
             <a:avLst/>
@@ -8779,124 +9791,46 @@
               <a:buNone/>
             </a:pPr>
             <a:r>
-              <a:rPr lang="en-US" sz="1600" b="1" spc="400" kern="0" dirty="0">
-                <a:solidFill>
-                  <a:srgbClr val="02C39A"/>
-                </a:solidFill>
-                <a:latin typeface="Calibri" pitchFamily="34" charset="0"/>
-                <a:ea typeface="Calibri" pitchFamily="34" charset="-122"/>
-                <a:cs typeface="Calibri" pitchFamily="34" charset="-120"/>
-              </a:rPr>
-              <a:t>NOW — LIVE</a:t>
-            </a:r>
-            <a:endParaRPr lang="en-US" sz="1600" dirty="0"/>
-          </a:p>
-        </p:txBody>
-      </p:sp>
-      <p:sp>
-        <p:nvSpPr>
-          <p:cNvPr id="6" name="Text 4"/>
-          <p:cNvSpPr/>
-          <p:nvPr/>
-        </p:nvSpPr>
-        <p:spPr>
-          <a:xfrm>
-            <a:off x="868680" y="2697480"/>
-            <a:ext cx="10058400" cy="1463040"/>
-          </a:xfrm>
-          <a:prstGeom prst="rect">
-            <a:avLst/>
-          </a:prstGeom>
-          <a:noFill/>
-          <a:ln/>
-        </p:spPr>
-        <p:txBody>
-          <a:bodyPr wrap="square" lIns="0" tIns="0" rIns="0" bIns="0" rtlCol="0" anchor="ctr"/>
-          <a:lstStyle/>
-          <a:p>
-            <a:pPr indent="0" marL="0">
-              <a:buNone/>
-            </a:pPr>
-            <a:r>
-              <a:rPr lang="en-US" sz="8000" b="1" dirty="0">
-                <a:solidFill>
-                  <a:srgbClr val="EAF0F8"/>
-                </a:solidFill>
-                <a:latin typeface="Calibri" pitchFamily="34" charset="0"/>
-                <a:ea typeface="Calibri" pitchFamily="34" charset="-122"/>
-                <a:cs typeface="Calibri" pitchFamily="34" charset="-120"/>
-              </a:rPr>
-              <a:t>Let's build it</a:t>
-            </a:r>
-            <a:endParaRPr lang="en-US" sz="8000" dirty="0"/>
-          </a:p>
-        </p:txBody>
-      </p:sp>
-      <p:sp>
-        <p:nvSpPr>
-          <p:cNvPr id="7" name="Text 5"/>
-          <p:cNvSpPr/>
-          <p:nvPr/>
-        </p:nvSpPr>
-        <p:spPr>
-          <a:xfrm>
-            <a:off x="914400" y="4343400"/>
-            <a:ext cx="10332720" cy="457200"/>
-          </a:xfrm>
-          <a:prstGeom prst="rect">
-            <a:avLst/>
-          </a:prstGeom>
-          <a:noFill/>
-          <a:ln/>
-        </p:spPr>
-        <p:txBody>
-          <a:bodyPr wrap="square" lIns="0" tIns="0" rIns="0" bIns="0" rtlCol="0" anchor="ctr"/>
-          <a:lstStyle/>
-          <a:p>
-            <a:pPr indent="0" marL="0">
-              <a:buNone/>
-            </a:pPr>
-            <a:r>
-              <a:rPr lang="en-US" sz="1800" dirty="0">
+              <a:rPr lang="en-US" sz="1300" i="1" dirty="0">
                 <a:solidFill>
                   <a:srgbClr val="00A896"/>
                 </a:solidFill>
-                <a:latin typeface="Courier New" pitchFamily="34" charset="0"/>
-                <a:ea typeface="Courier New" pitchFamily="34" charset="-122"/>
-                <a:cs typeface="Courier New" pitchFamily="34" charset="-120"/>
-              </a:rPr>
-              <a:t>Open JupyterLab → notebooks/01_langchain.ipynb</a:t>
-            </a:r>
-            <a:endParaRPr lang="en-US" sz="1800" dirty="0"/>
-          </a:p>
-        </p:txBody>
-      </p:sp>
-      <p:sp>
-        <p:nvSpPr>
-          <p:cNvPr id="8" name="Text 6"/>
-          <p:cNvSpPr/>
-          <p:nvPr/>
-        </p:nvSpPr>
-        <p:spPr>
-          <a:xfrm>
-            <a:off x="914400" y="4983480"/>
-            <a:ext cx="10058400" cy="365760"/>
-          </a:xfrm>
-          <a:prstGeom prst="rect">
-            <a:avLst/>
-          </a:prstGeom>
-          <a:noFill/>
-          <a:ln/>
-        </p:spPr>
-        <p:txBody>
-          <a:bodyPr wrap="square" lIns="0" tIns="0" rIns="0" bIns="0" rtlCol="0" anchor="ctr"/>
-          <a:lstStyle/>
-          <a:p>
-            <a:pPr indent="0" marL="0">
-              <a:buNone/>
-            </a:pPr>
-            <a:r>
-              <a:rPr lang="en-US" sz="1400" dirty="0">
+                <a:latin typeface="Calibri" pitchFamily="34" charset="0"/>
+                <a:ea typeface="Calibri" pitchFamily="34" charset="-122"/>
+                <a:cs typeface="Calibri" pitchFamily="34" charset="-120"/>
+              </a:rPr>
+              <a:t>Plus:  langgraph dev  →  open LangGraph Studio to watch the graph run, inspect state, fork &amp; replay.</a:t>
+            </a:r>
+            <a:endParaRPr lang="en-US" sz="1300" dirty="0"/>
+          </a:p>
+        </p:txBody>
+      </p:sp>
+      <p:sp>
+        <p:nvSpPr>
+          <p:cNvPr id="27" name="Text 25"/>
+          <p:cNvSpPr/>
+          <p:nvPr/>
+        </p:nvSpPr>
+        <p:spPr>
+          <a:xfrm>
+            <a:off x="457200" y="6455664"/>
+            <a:ext cx="8229600" cy="274320"/>
+          </a:xfrm>
+          <a:prstGeom prst="rect">
+            <a:avLst/>
+          </a:prstGeom>
+          <a:noFill/>
+          <a:ln/>
+        </p:spPr>
+        <p:txBody>
+          <a:bodyPr wrap="square" rtlCol="0" anchor="ctr"/>
+          <a:lstStyle/>
+          <a:p>
+            <a:pPr indent="0" marL="0">
+              <a:buNone/>
+            </a:pPr>
+            <a:r>
+              <a:rPr lang="en-US" sz="900" dirty="0">
                 <a:solidFill>
                   <a:srgbClr val="9AAAC4"/>
                 </a:solidFill>
@@ -8904,9 +9838,48 @@
                 <a:ea typeface="Calibri" pitchFamily="34" charset="-122"/>
                 <a:cs typeface="Calibri" pitchFamily="34" charset="-120"/>
               </a:rPr>
-              <a:t>Run top to bottom · do the 🧪 Your turn cells</a:t>
-            </a:r>
-            <a:endParaRPr lang="en-US" sz="1400" dirty="0"/>
+              <a:t>LangChain &amp; LangGraph · Hands-on</a:t>
+            </a:r>
+            <a:endParaRPr lang="en-US" sz="900" dirty="0"/>
+          </a:p>
+        </p:txBody>
+      </p:sp>
+      <p:sp>
+        <p:nvSpPr>
+          <p:cNvPr id="28" name="Text 26"/>
+          <p:cNvSpPr/>
+          <p:nvPr/>
+        </p:nvSpPr>
+        <p:spPr>
+          <a:xfrm>
+            <a:off x="11430000" y="6455664"/>
+            <a:ext cx="457200" cy="274320"/>
+          </a:xfrm>
+          <a:prstGeom prst="rect">
+            <a:avLst/>
+          </a:prstGeom>
+          <a:noFill/>
+          <a:ln/>
+        </p:spPr>
+        <p:txBody>
+          <a:bodyPr wrap="square" rtlCol="0" anchor="ctr"/>
+          <a:lstStyle/>
+          <a:p>
+            <a:pPr algn="r" indent="0" marL="0">
+              <a:buNone/>
+            </a:pPr>
+            <a:r>
+              <a:rPr lang="en-US" sz="900" dirty="0">
+                <a:solidFill>
+                  <a:srgbClr val="9AAAC4"/>
+                </a:solidFill>
+                <a:latin typeface="Calibri" pitchFamily="34" charset="0"/>
+                <a:ea typeface="Calibri" pitchFamily="34" charset="-122"/>
+                <a:cs typeface="Calibri" pitchFamily="34" charset="-120"/>
+              </a:rPr>
+              <a:t>8</a:t>
+            </a:r>
+            <a:endParaRPr lang="en-US" sz="900" dirty="0"/>
           </a:p>
         </p:txBody>
       </p:sp>
@@ -8950,8 +9923,8 @@
         </p:nvSpPr>
         <p:spPr>
           <a:xfrm>
-            <a:off x="-1828800" y="4023360"/>
-            <a:ext cx="5486400" cy="5486400"/>
+            <a:off x="-2011680" y="3291840"/>
+            <a:ext cx="6400800" cy="6400800"/>
           </a:xfrm>
           <a:prstGeom prst="ellipse">
             <a:avLst/>
@@ -8975,8 +9948,8 @@
         </p:nvSpPr>
         <p:spPr>
           <a:xfrm>
-            <a:off x="9601200" y="-2011680"/>
-            <a:ext cx="5029200" cy="5029200"/>
+            <a:off x="9326880" y="-2377440"/>
+            <a:ext cx="5486400" cy="5486400"/>
           </a:xfrm>
           <a:prstGeom prst="ellipse">
             <a:avLst/>
@@ -8994,123 +9967,20 @@
       </p:sp>
       <p:sp>
         <p:nvSpPr>
-          <p:cNvPr id="4" name="Text 2"/>
-          <p:cNvSpPr/>
-          <p:nvPr/>
-        </p:nvSpPr>
-        <p:spPr>
-          <a:xfrm>
-            <a:off x="914400" y="1554480"/>
-            <a:ext cx="9144000" cy="365760"/>
-          </a:xfrm>
-          <a:prstGeom prst="rect">
-            <a:avLst/>
-          </a:prstGeom>
-          <a:noFill/>
-          <a:ln/>
-        </p:spPr>
-        <p:txBody>
-          <a:bodyPr wrap="square" lIns="0" tIns="0" rIns="0" bIns="0" rtlCol="0" anchor="ctr"/>
-          <a:lstStyle/>
-          <a:p>
-            <a:pPr indent="0" marL="0">
-              <a:buNone/>
-            </a:pPr>
-            <a:r>
-              <a:rPr lang="en-US" sz="1400" b="1" spc="300" kern="0" dirty="0">
-                <a:solidFill>
-                  <a:srgbClr val="02C39A"/>
-                </a:solidFill>
-                <a:latin typeface="Calibri" pitchFamily="34" charset="0"/>
-                <a:ea typeface="Calibri" pitchFamily="34" charset="-122"/>
-                <a:cs typeface="Calibri" pitchFamily="34" charset="-120"/>
-              </a:rPr>
-              <a:t>KEY TAKEAWAY</a:t>
-            </a:r>
-            <a:endParaRPr lang="en-US" sz="1400" dirty="0"/>
-          </a:p>
-        </p:txBody>
-      </p:sp>
-      <p:sp>
-        <p:nvSpPr>
-          <p:cNvPr id="5" name="Text 3"/>
-          <p:cNvSpPr/>
-          <p:nvPr/>
-        </p:nvSpPr>
-        <p:spPr>
-          <a:xfrm>
-            <a:off x="914400" y="1965960"/>
-            <a:ext cx="10424160" cy="1645920"/>
-          </a:xfrm>
-          <a:prstGeom prst="rect">
-            <a:avLst/>
-          </a:prstGeom>
-          <a:noFill/>
-          <a:ln/>
-        </p:spPr>
-        <p:txBody>
-          <a:bodyPr wrap="square" lIns="0" tIns="0" rIns="0" bIns="0" rtlCol="0" anchor="ctr"/>
-          <a:lstStyle/>
-          <a:p>
-            <a:pPr indent="0" marL="0">
-              <a:lnSpc>
-                <a:spcPct val="100000"/>
-              </a:lnSpc>
-              <a:buNone/>
-            </a:pPr>
-            <a:r>
-              <a:rPr lang="en-US" sz="3600" b="1" dirty="0">
-                <a:solidFill>
-                  <a:srgbClr val="EAF0F8"/>
-                </a:solidFill>
-                <a:latin typeface="Calibri" pitchFamily="34" charset="0"/>
-                <a:ea typeface="Calibri" pitchFamily="34" charset="-122"/>
-                <a:cs typeface="Calibri" pitchFamily="34" charset="-120"/>
-              </a:rPr>
-              <a:t>LangChain builds the pieces.</a:t>
-            </a:r>
-            <a:endParaRPr lang="en-US" sz="3600" dirty="0"/>
-          </a:p>
-          <a:p>
-            <a:pPr indent="0" marL="0">
-              <a:lnSpc>
-                <a:spcPct val="100000"/>
-              </a:lnSpc>
-              <a:buNone/>
-            </a:pPr>
-            <a:r>
-              <a:rPr lang="en-US" sz="3600" b="1" dirty="0">
-                <a:solidFill>
-                  <a:srgbClr val="EAF0F8"/>
-                </a:solidFill>
-                <a:latin typeface="Calibri" pitchFamily="34" charset="0"/>
-                <a:ea typeface="Calibri" pitchFamily="34" charset="-122"/>
-                <a:cs typeface="Calibri" pitchFamily="34" charset="-120"/>
-              </a:rPr>
-              <a:t>LangGraph makes them an agent.</a:t>
-            </a:r>
-            <a:endParaRPr lang="en-US" sz="3600" dirty="0"/>
-          </a:p>
-        </p:txBody>
-      </p:sp>
-      <p:sp>
-        <p:nvSpPr>
-          <p:cNvPr id="6" name="Shape 4"/>
-          <p:cNvSpPr/>
-          <p:nvPr/>
-        </p:nvSpPr>
-        <p:spPr>
-          <a:xfrm>
-            <a:off x="914400" y="3794760"/>
-            <a:ext cx="10332720" cy="1371600"/>
-          </a:xfrm>
-          <a:prstGeom prst="roundRect">
-            <a:avLst>
-              <a:gd name="adj" fmla="val 6667"/>
-            </a:avLst>
+          <p:cNvPr id="4" name="Shape 2"/>
+          <p:cNvSpPr/>
+          <p:nvPr/>
+        </p:nvSpPr>
+        <p:spPr>
+          <a:xfrm>
+            <a:off x="10424160" y="4206240"/>
+            <a:ext cx="3108960" cy="3108960"/>
+          </a:xfrm>
+          <a:prstGeom prst="ellipse">
+            <a:avLst/>
           </a:prstGeom>
           <a:solidFill>
-            <a:srgbClr val="16233F"/>
+            <a:srgbClr val="0B1220"/>
           </a:solidFill>
           <a:ln w="19050">
             <a:solidFill>
@@ -9118,14 +9988,85 @@
             </a:solidFill>
             <a:prstDash val="solid"/>
           </a:ln>
-          <a:effectLst>
-            <a:outerShdw sx="100000" sy="100000" kx="0" ky="0" algn="bl" rotWithShape="0" blurRad="101600" dist="38100" dir="5400000">
-              <a:srgbClr val="000000">
-                <a:alpha val="35000"/>
-              </a:srgbClr>
-            </a:outerShdw>
-          </a:effectLst>
-        </p:spPr>
+        </p:spPr>
+      </p:sp>
+      <p:sp>
+        <p:nvSpPr>
+          <p:cNvPr id="5" name="Text 3"/>
+          <p:cNvSpPr/>
+          <p:nvPr/>
+        </p:nvSpPr>
+        <p:spPr>
+          <a:xfrm>
+            <a:off x="914400" y="2331720"/>
+            <a:ext cx="9144000" cy="457200"/>
+          </a:xfrm>
+          <a:prstGeom prst="rect">
+            <a:avLst/>
+          </a:prstGeom>
+          <a:noFill/>
+          <a:ln/>
+        </p:spPr>
+        <p:txBody>
+          <a:bodyPr wrap="square" lIns="0" tIns="0" rIns="0" bIns="0" rtlCol="0" anchor="ctr"/>
+          <a:lstStyle/>
+          <a:p>
+            <a:pPr indent="0" marL="0">
+              <a:buNone/>
+            </a:pPr>
+            <a:r>
+              <a:rPr lang="en-US" sz="1600" b="1" spc="400" kern="0" dirty="0">
+                <a:solidFill>
+                  <a:srgbClr val="02C39A"/>
+                </a:solidFill>
+                <a:latin typeface="Calibri" pitchFamily="34" charset="0"/>
+                <a:ea typeface="Calibri" pitchFamily="34" charset="-122"/>
+                <a:cs typeface="Calibri" pitchFamily="34" charset="-120"/>
+              </a:rPr>
+              <a:t>NOW — LIVE</a:t>
+            </a:r>
+            <a:endParaRPr lang="en-US" sz="1600" dirty="0"/>
+          </a:p>
+        </p:txBody>
+      </p:sp>
+      <p:sp>
+        <p:nvSpPr>
+          <p:cNvPr id="6" name="Text 4"/>
+          <p:cNvSpPr/>
+          <p:nvPr/>
+        </p:nvSpPr>
+        <p:spPr>
+          <a:xfrm>
+            <a:off x="868680" y="2697480"/>
+            <a:ext cx="10058400" cy="1463040"/>
+          </a:xfrm>
+          <a:prstGeom prst="rect">
+            <a:avLst/>
+          </a:prstGeom>
+          <a:noFill/>
+          <a:ln/>
+        </p:spPr>
+        <p:txBody>
+          <a:bodyPr wrap="square" lIns="0" tIns="0" rIns="0" bIns="0" rtlCol="0" anchor="ctr"/>
+          <a:lstStyle/>
+          <a:p>
+            <a:pPr indent="0" marL="0">
+              <a:buNone/>
+            </a:pPr>
+            <a:r>
+              <a:rPr lang="en-US" sz="8000" b="1" dirty="0">
+                <a:solidFill>
+                  <a:srgbClr val="EAF0F8"/>
+                </a:solidFill>
+                <a:latin typeface="Calibri" pitchFamily="34" charset="0"/>
+                <a:ea typeface="Calibri" pitchFamily="34" charset="-122"/>
+                <a:cs typeface="Calibri" pitchFamily="34" charset="-120"/>
+              </a:rPr>
+              <a:t>Let's build it</a:t>
+            </a:r>
+            <a:endParaRPr lang="en-US" sz="8000" dirty="0"/>
+          </a:p>
+        </p:txBody>
       </p:sp>
       <p:sp>
         <p:nvSpPr>
@@ -9135,8 +10076,8 @@
         </p:nvSpPr>
         <p:spPr>
           <a:xfrm>
-            <a:off x="1188720" y="3977640"/>
-            <a:ext cx="9784080" cy="457200"/>
+            <a:off x="914400" y="4343400"/>
+            <a:ext cx="10332720" cy="457200"/>
           </a:xfrm>
           <a:prstGeom prst="rect">
             <a:avLst/>
@@ -9152,15 +10093,15 @@
               <a:buNone/>
             </a:pPr>
             <a:r>
-              <a:rPr lang="en-US" sz="1800" b="1" dirty="0">
-                <a:solidFill>
-                  <a:srgbClr val="EAF0F8"/>
-                </a:solidFill>
-                <a:latin typeface="Calibri" pitchFamily="34" charset="0"/>
-                <a:ea typeface="Calibri" pitchFamily="34" charset="-122"/>
-                <a:cs typeface="Calibri" pitchFamily="34" charset="-120"/>
-              </a:rPr>
-              <a:t>Chains flow one way; agents loop, remember, branch, and pause for you.</a:t>
+              <a:rPr lang="en-US" sz="1800" dirty="0">
+                <a:solidFill>
+                  <a:srgbClr val="00A896"/>
+                </a:solidFill>
+                <a:latin typeface="Courier New" pitchFamily="34" charset="0"/>
+                <a:ea typeface="Courier New" pitchFamily="34" charset="-122"/>
+                <a:cs typeface="Courier New" pitchFamily="34" charset="-120"/>
+              </a:rPr>
+              <a:t>Open JupyterLab → notebooks/01_langchain.ipynb</a:t>
             </a:r>
             <a:endParaRPr lang="en-US" sz="1800" dirty="0"/>
           </a:p>
@@ -9174,8 +10115,8 @@
         </p:nvSpPr>
         <p:spPr>
           <a:xfrm>
-            <a:off x="1188720" y="4526280"/>
-            <a:ext cx="9784080" cy="457200"/>
+            <a:off x="914400" y="4983480"/>
+            <a:ext cx="10058400" cy="365760"/>
           </a:xfrm>
           <a:prstGeom prst="rect">
             <a:avLst/>
@@ -9191,56 +10132,17 @@
               <a:buNone/>
             </a:pPr>
             <a:r>
-              <a:rPr lang="en-US" sz="1450" i="1" dirty="0">
-                <a:solidFill>
-                  <a:srgbClr val="00A896"/>
-                </a:solidFill>
-                <a:latin typeface="Calibri" pitchFamily="34" charset="0"/>
-                <a:ea typeface="Calibri" pitchFamily="34" charset="-122"/>
-                <a:cs typeface="Calibri" pitchFamily="34" charset="-120"/>
-              </a:rPr>
-              <a:t>You now have both — plus the notebooks to keep building.</a:t>
-            </a:r>
-            <a:endParaRPr lang="en-US" sz="1450" dirty="0"/>
-          </a:p>
-        </p:txBody>
-      </p:sp>
-      <p:sp>
-        <p:nvSpPr>
-          <p:cNvPr id="9" name="Text 7"/>
-          <p:cNvSpPr/>
-          <p:nvPr/>
-        </p:nvSpPr>
-        <p:spPr>
-          <a:xfrm>
-            <a:off x="914400" y="5532120"/>
-            <a:ext cx="5486400" cy="457200"/>
-          </a:xfrm>
-          <a:prstGeom prst="rect">
-            <a:avLst/>
-          </a:prstGeom>
-          <a:noFill/>
-          <a:ln/>
-        </p:spPr>
-        <p:txBody>
-          <a:bodyPr wrap="square" lIns="0" tIns="0" rIns="0" bIns="0" rtlCol="0" anchor="ctr"/>
-          <a:lstStyle/>
-          <a:p>
-            <a:pPr indent="0" marL="0">
-              <a:buNone/>
-            </a:pPr>
-            <a:r>
-              <a:rPr lang="en-US" sz="2200" b="1" dirty="0">
-                <a:solidFill>
-                  <a:srgbClr val="02C39A"/>
-                </a:solidFill>
-                <a:latin typeface="Calibri" pitchFamily="34" charset="0"/>
-                <a:ea typeface="Calibri" pitchFamily="34" charset="-122"/>
-                <a:cs typeface="Calibri" pitchFamily="34" charset="-120"/>
-              </a:rPr>
-              <a:t>Questions?</a:t>
-            </a:r>
-            <a:endParaRPr lang="en-US" sz="2200" dirty="0"/>
+              <a:rPr lang="en-US" sz="1400" dirty="0">
+                <a:solidFill>
+                  <a:srgbClr val="9AAAC4"/>
+                </a:solidFill>
+                <a:latin typeface="Calibri" pitchFamily="34" charset="0"/>
+                <a:ea typeface="Calibri" pitchFamily="34" charset="-122"/>
+                <a:cs typeface="Calibri" pitchFamily="34" charset="-120"/>
+              </a:rPr>
+              <a:t>Run top to bottom · do the 🧪 Your turn cells</a:t>
+            </a:r>
+            <a:endParaRPr lang="en-US" sz="1400" dirty="0"/>
           </a:p>
         </p:txBody>
       </p:sp>

</xml_diff>